<commit_message>
ADD Customized chart Matplotlib
</commit_message>
<xml_diff>
--- a/Chart_Customize/customized_chart.pptx
+++ b/Chart_Customize/customized_chart.pptx
@@ -8,7 +8,6 @@
     <p:sldId id="256" r:id="rId3"/>
     <p:sldId id="257" r:id="rId4"/>
     <p:sldId id="258" r:id="rId5"/>
-    <p:sldId id="259" r:id="rId6"/>
   </p:sldIdLst>
   <p:sldSz cx="10080625" cy="5670550"/>
   <p:notesSz cx="7559675" cy="10691813"/>
@@ -41,7 +40,7 @@
         <p:spPr>
           <a:xfrm>
             <a:off x="0" y="5400000"/>
-            <a:ext cx="10080000" cy="270000"/>
+            <a:ext cx="10079640" cy="269640"/>
           </a:xfrm>
           <a:prstGeom prst="rect">
             <a:avLst/>
@@ -64,6 +63,11 @@
             <a:spAutoFit/>
           </a:bodyPr>
           <a:p>
+            <a:pPr>
+              <a:lnSpc>
+                <a:spcPct val="100000"/>
+              </a:lnSpc>
+            </a:pPr>
             <a:endParaRPr b="1" lang="en-IN" sz="1400" strike="noStrike" u="none">
               <a:solidFill>
                 <a:srgbClr val="ffffff"/>
@@ -71,6 +75,7 @@
               <a:effectLst/>
               <a:uFillTx/>
               <a:latin typeface="Noto Sans"/>
+              <a:ea typeface="DejaVu Sans"/>
             </a:endParaRPr>
           </a:p>
         </p:txBody>
@@ -84,7 +89,7 @@
         <p:spPr>
           <a:xfrm>
             <a:off x="0" y="0"/>
-            <a:ext cx="10080000" cy="1215000"/>
+            <a:ext cx="10079640" cy="1214640"/>
           </a:xfrm>
           <a:prstGeom prst="rect">
             <a:avLst/>
@@ -107,6 +112,11 @@
             <a:spAutoFit/>
           </a:bodyPr>
           <a:p>
+            <a:pPr>
+              <a:lnSpc>
+                <a:spcPct val="100000"/>
+              </a:lnSpc>
+            </a:pPr>
             <a:endParaRPr b="1" lang="en-IN" sz="1400" strike="noStrike" u="none">
               <a:solidFill>
                 <a:srgbClr val="ffffff"/>
@@ -114,6 +124,7 @@
               <a:effectLst/>
               <a:uFillTx/>
               <a:latin typeface="Noto Sans"/>
+              <a:ea typeface="DejaVu Sans"/>
             </a:endParaRPr>
           </a:p>
         </p:txBody>
@@ -127,7 +138,7 @@
         <p:spPr>
           <a:xfrm>
             <a:off x="9315000" y="5175000"/>
-            <a:ext cx="450000" cy="450000"/>
+            <a:ext cx="449640" cy="449640"/>
           </a:xfrm>
           <a:prstGeom prst="ellipse">
             <a:avLst/>
@@ -152,6 +163,11 @@
             <a:spAutoFit/>
           </a:bodyPr>
           <a:p>
+            <a:pPr>
+              <a:lnSpc>
+                <a:spcPct val="100000"/>
+              </a:lnSpc>
+            </a:pPr>
             <a:endParaRPr b="1" lang="en-IN" sz="1400" strike="noStrike" u="none">
               <a:solidFill>
                 <a:srgbClr val="ffffff"/>
@@ -159,6 +175,7 @@
               <a:effectLst/>
               <a:uFillTx/>
               <a:latin typeface="Noto Sans"/>
+              <a:ea typeface="DejaVu Sans"/>
             </a:endParaRPr>
           </a:p>
         </p:txBody>
@@ -176,7 +193,7 @@
         <p:spPr>
           <a:xfrm>
             <a:off x="360000" y="225720"/>
-            <a:ext cx="9360000" cy="718920"/>
+            <a:ext cx="9359640" cy="718560"/>
           </a:xfrm>
           <a:prstGeom prst="rect">
             <a:avLst/>
@@ -192,7 +209,13 @@
           </a:bodyPr>
           <a:p>
             <a:pPr indent="0">
-              <a:buNone/>
+              <a:lnSpc>
+                <a:spcPct val="100000"/>
+              </a:lnSpc>
+              <a:buNone/>
+              <a:tabLst>
+                <a:tab algn="l" pos="0"/>
+              </a:tabLst>
             </a:pPr>
             <a:r>
               <a:rPr b="1" lang="en-IN" sz="3200" strike="noStrike" u="none">
@@ -205,13 +228,13 @@
               </a:rPr>
               <a:t>Click to edit the title text format</a:t>
             </a:r>
-            <a:endParaRPr b="1" lang="en-IN" sz="3200" strike="noStrike" u="none">
-              <a:solidFill>
-                <a:srgbClr val="ffffff"/>
-              </a:solidFill>
-              <a:effectLst/>
-              <a:uFillTx/>
-              <a:latin typeface="Noto Sans"/>
+            <a:endParaRPr b="0" lang="en-IN" sz="3200" strike="noStrike" u="none">
+              <a:solidFill>
+                <a:srgbClr val="000000"/>
+              </a:solidFill>
+              <a:effectLst/>
+              <a:uFillTx/>
+              <a:latin typeface="Arial"/>
             </a:endParaRPr>
           </a:p>
         </p:txBody>
@@ -229,7 +252,7 @@
         <p:spPr>
           <a:xfrm>
             <a:off x="360000" y="1485000"/>
-            <a:ext cx="9360000" cy="3780000"/>
+            <a:ext cx="9359640" cy="3779640"/>
           </a:xfrm>
           <a:prstGeom prst="rect">
             <a:avLst/>
@@ -245,6 +268,9 @@
           </a:bodyPr>
           <a:p>
             <a:pPr marL="432000" indent="-324000">
+              <a:lnSpc>
+                <a:spcPct val="100000"/>
+              </a:lnSpc>
               <a:spcAft>
                 <a:spcPts val="1057"/>
               </a:spcAft>
@@ -266,17 +292,20 @@
               </a:rPr>
               <a:t>Click to edit the outline text format</a:t>
             </a:r>
-            <a:endParaRPr b="1" lang="en-IN" sz="2400" strike="noStrike" u="none">
-              <a:solidFill>
-                <a:srgbClr val="2c3e50"/>
-              </a:solidFill>
-              <a:effectLst/>
-              <a:uFillTx/>
-              <a:latin typeface="Noto Sans"/>
+            <a:endParaRPr b="0" lang="en-IN" sz="2400" strike="noStrike" u="none">
+              <a:solidFill>
+                <a:srgbClr val="000000"/>
+              </a:solidFill>
+              <a:effectLst/>
+              <a:uFillTx/>
+              <a:latin typeface="Arial"/>
             </a:endParaRPr>
           </a:p>
           <a:p>
             <a:pPr lvl="1" marL="864000" indent="-324000">
+              <a:lnSpc>
+                <a:spcPct val="100000"/>
+              </a:lnSpc>
               <a:spcAft>
                 <a:spcPts val="850"/>
               </a:spcAft>
@@ -300,15 +329,18 @@
             </a:r>
             <a:endParaRPr b="0" lang="en-IN" sz="2100" strike="noStrike" u="none">
               <a:solidFill>
-                <a:srgbClr val="2c3e50"/>
-              </a:solidFill>
-              <a:effectLst/>
-              <a:uFillTx/>
-              <a:latin typeface="Noto Sans"/>
+                <a:srgbClr val="000000"/>
+              </a:solidFill>
+              <a:effectLst/>
+              <a:uFillTx/>
+              <a:latin typeface="Arial"/>
             </a:endParaRPr>
           </a:p>
           <a:p>
             <a:pPr lvl="2" marL="1296000" indent="-288000">
+              <a:lnSpc>
+                <a:spcPct val="100000"/>
+              </a:lnSpc>
               <a:spcAft>
                 <a:spcPts val="635"/>
               </a:spcAft>
@@ -332,15 +364,18 @@
             </a:r>
             <a:endParaRPr b="0" lang="en-IN" sz="1800" strike="noStrike" u="none">
               <a:solidFill>
-                <a:srgbClr val="2c3e50"/>
-              </a:solidFill>
-              <a:effectLst/>
-              <a:uFillTx/>
-              <a:latin typeface="Noto Sans"/>
+                <a:srgbClr val="000000"/>
+              </a:solidFill>
+              <a:effectLst/>
+              <a:uFillTx/>
+              <a:latin typeface="Arial"/>
             </a:endParaRPr>
           </a:p>
           <a:p>
             <a:pPr lvl="3" marL="1728000" indent="-216000">
+              <a:lnSpc>
+                <a:spcPct val="100000"/>
+              </a:lnSpc>
               <a:spcAft>
                 <a:spcPts val="425"/>
               </a:spcAft>
@@ -364,15 +399,18 @@
             </a:r>
             <a:endParaRPr b="0" lang="en-IN" sz="1500" strike="noStrike" u="none">
               <a:solidFill>
-                <a:srgbClr val="2c3e50"/>
-              </a:solidFill>
-              <a:effectLst/>
-              <a:uFillTx/>
-              <a:latin typeface="Noto Sans"/>
+                <a:srgbClr val="000000"/>
+              </a:solidFill>
+              <a:effectLst/>
+              <a:uFillTx/>
+              <a:latin typeface="Arial"/>
             </a:endParaRPr>
           </a:p>
           <a:p>
             <a:pPr lvl="4" marL="2160000" indent="-216000">
+              <a:lnSpc>
+                <a:spcPct val="100000"/>
+              </a:lnSpc>
               <a:spcAft>
                 <a:spcPts val="213"/>
               </a:spcAft>
@@ -396,15 +434,18 @@
             </a:r>
             <a:endParaRPr b="0" lang="en-IN" sz="1500" strike="noStrike" u="none">
               <a:solidFill>
-                <a:srgbClr val="2c3e50"/>
-              </a:solidFill>
-              <a:effectLst/>
-              <a:uFillTx/>
-              <a:latin typeface="Noto Sans"/>
+                <a:srgbClr val="000000"/>
+              </a:solidFill>
+              <a:effectLst/>
+              <a:uFillTx/>
+              <a:latin typeface="Arial"/>
             </a:endParaRPr>
           </a:p>
           <a:p>
             <a:pPr lvl="5" marL="2592000" indent="-216000">
+              <a:lnSpc>
+                <a:spcPct val="100000"/>
+              </a:lnSpc>
               <a:spcAft>
                 <a:spcPts val="213"/>
               </a:spcAft>
@@ -428,15 +469,18 @@
             </a:r>
             <a:endParaRPr b="0" lang="en-IN" sz="1500" strike="noStrike" u="none">
               <a:solidFill>
-                <a:srgbClr val="2c3e50"/>
-              </a:solidFill>
-              <a:effectLst/>
-              <a:uFillTx/>
-              <a:latin typeface="Noto Sans"/>
+                <a:srgbClr val="000000"/>
+              </a:solidFill>
+              <a:effectLst/>
+              <a:uFillTx/>
+              <a:latin typeface="Arial"/>
             </a:endParaRPr>
           </a:p>
           <a:p>
             <a:pPr lvl="6" marL="3024000" indent="-216000">
+              <a:lnSpc>
+                <a:spcPct val="100000"/>
+              </a:lnSpc>
               <a:spcAft>
                 <a:spcPts val="213"/>
               </a:spcAft>
@@ -460,11 +504,11 @@
             </a:r>
             <a:endParaRPr b="0" lang="en-IN" sz="1500" strike="noStrike" u="none">
               <a:solidFill>
-                <a:srgbClr val="2c3e50"/>
-              </a:solidFill>
-              <a:effectLst/>
-              <a:uFillTx/>
-              <a:latin typeface="Noto Sans"/>
+                <a:srgbClr val="000000"/>
+              </a:solidFill>
+              <a:effectLst/>
+              <a:uFillTx/>
+              <a:latin typeface="Arial"/>
             </a:endParaRPr>
           </a:p>
         </p:txBody>
@@ -482,7 +526,7 @@
         <p:spPr>
           <a:xfrm>
             <a:off x="360000" y="5400000"/>
-            <a:ext cx="2880000" cy="311400"/>
+            <a:ext cx="2879640" cy="311400"/>
           </a:xfrm>
           <a:prstGeom prst="rect">
             <a:avLst/>
@@ -498,7 +542,13 @@
           </a:bodyPr>
           <a:lstStyle>
             <a:lvl1pPr indent="0">
-              <a:buNone/>
+              <a:lnSpc>
+                <a:spcPct val="100000"/>
+              </a:lnSpc>
+              <a:buNone/>
+              <a:tabLst>
+                <a:tab algn="l" pos="0"/>
+              </a:tabLst>
               <a:defRPr b="1" lang="en-IN" sz="1800" strike="noStrike" u="none">
                 <a:solidFill>
                   <a:srgbClr val="ffffff"/>
@@ -511,7 +561,13 @@
           </a:lstStyle>
           <a:p>
             <a:pPr indent="0">
-              <a:buNone/>
+              <a:lnSpc>
+                <a:spcPct val="100000"/>
+              </a:lnSpc>
+              <a:buNone/>
+              <a:tabLst>
+                <a:tab algn="l" pos="0"/>
+              </a:tabLst>
             </a:pPr>
             <a:r>
               <a:rPr b="1" lang="en-IN" sz="1800" strike="noStrike" u="none">
@@ -524,13 +580,13 @@
               </a:rPr>
               <a:t>&lt;date/time&gt;</a:t>
             </a:r>
-            <a:endParaRPr b="1" lang="en-IN" sz="1800" strike="noStrike" u="none">
-              <a:solidFill>
-                <a:srgbClr val="ffffff"/>
-              </a:solidFill>
-              <a:effectLst/>
-              <a:uFillTx/>
-              <a:latin typeface="Noto Sans"/>
+            <a:endParaRPr b="0" lang="en-IN" sz="1800" strike="noStrike" u="none">
+              <a:solidFill>
+                <a:srgbClr val="000000"/>
+              </a:solidFill>
+              <a:effectLst/>
+              <a:uFillTx/>
+              <a:latin typeface="Times New Roman"/>
             </a:endParaRPr>
           </a:p>
         </p:txBody>
@@ -548,7 +604,7 @@
         <p:spPr>
           <a:xfrm>
             <a:off x="3420000" y="5400000"/>
-            <a:ext cx="3240000" cy="311400"/>
+            <a:ext cx="3239640" cy="311400"/>
           </a:xfrm>
           <a:prstGeom prst="rect">
             <a:avLst/>
@@ -564,7 +620,13 @@
           </a:bodyPr>
           <a:lstStyle>
             <a:lvl1pPr indent="0" algn="ctr">
-              <a:buNone/>
+              <a:lnSpc>
+                <a:spcPct val="100000"/>
+              </a:lnSpc>
+              <a:buNone/>
+              <a:tabLst>
+                <a:tab algn="l" pos="0"/>
+              </a:tabLst>
               <a:defRPr b="1" lang="en-IN" sz="1800" strike="noStrike" u="none">
                 <a:solidFill>
                   <a:srgbClr val="ffffff"/>
@@ -577,7 +639,13 @@
           </a:lstStyle>
           <a:p>
             <a:pPr indent="0" algn="ctr">
-              <a:buNone/>
+              <a:lnSpc>
+                <a:spcPct val="100000"/>
+              </a:lnSpc>
+              <a:buNone/>
+              <a:tabLst>
+                <a:tab algn="l" pos="0"/>
+              </a:tabLst>
             </a:pPr>
             <a:r>
               <a:rPr b="1" lang="en-IN" sz="1800" strike="noStrike" u="none">
@@ -590,13 +658,13 @@
               </a:rPr>
               <a:t>&lt;footer&gt;</a:t>
             </a:r>
-            <a:endParaRPr b="1" lang="en-IN" sz="1800" strike="noStrike" u="none">
-              <a:solidFill>
-                <a:srgbClr val="ffffff"/>
-              </a:solidFill>
-              <a:effectLst/>
-              <a:uFillTx/>
-              <a:latin typeface="Noto Sans"/>
+            <a:endParaRPr b="0" lang="en-IN" sz="1800" strike="noStrike" u="none">
+              <a:solidFill>
+                <a:srgbClr val="000000"/>
+              </a:solidFill>
+              <a:effectLst/>
+              <a:uFillTx/>
+              <a:latin typeface="Times New Roman"/>
             </a:endParaRPr>
           </a:p>
         </p:txBody>
@@ -613,8 +681,8 @@
         </p:nvSpPr>
         <p:spPr>
           <a:xfrm>
-            <a:off x="9180000" y="5175000"/>
-            <a:ext cx="720000" cy="450000"/>
+            <a:off x="9180000" y="5262480"/>
+            <a:ext cx="719640" cy="274680"/>
           </a:xfrm>
           <a:prstGeom prst="rect">
             <a:avLst/>
@@ -630,7 +698,13 @@
           </a:bodyPr>
           <a:lstStyle>
             <a:lvl1pPr indent="0" algn="ctr">
-              <a:buNone/>
+              <a:lnSpc>
+                <a:spcPct val="100000"/>
+              </a:lnSpc>
+              <a:buNone/>
+              <a:tabLst>
+                <a:tab algn="l" pos="0"/>
+              </a:tabLst>
               <a:defRPr b="1" lang="en-IN" sz="1800" strike="noStrike" u="none">
                 <a:solidFill>
                   <a:srgbClr val="ffffff"/>
@@ -643,9 +717,15 @@
           </a:lstStyle>
           <a:p>
             <a:pPr indent="0" algn="ctr">
-              <a:buNone/>
-            </a:pPr>
-            <a:fld id="{2368CE2A-145D-4BD7-BA70-C3F56D7D9671}" type="slidenum">
+              <a:lnSpc>
+                <a:spcPct val="100000"/>
+              </a:lnSpc>
+              <a:buNone/>
+              <a:tabLst>
+                <a:tab algn="l" pos="0"/>
+              </a:tabLst>
+            </a:pPr>
+            <a:fld id="{8541513F-C598-4B5E-A357-F86CE4823935}" type="slidenum">
               <a:rPr b="1" lang="en-IN" sz="1800" strike="noStrike" u="none">
                 <a:solidFill>
                   <a:srgbClr val="ffffff"/>
@@ -656,13 +736,13 @@
               </a:rPr>
               <a:t>&lt;number&gt;</a:t>
             </a:fld>
-            <a:endParaRPr b="1" lang="en-IN" sz="1800" strike="noStrike" u="none">
-              <a:solidFill>
-                <a:srgbClr val="ffffff"/>
-              </a:solidFill>
-              <a:effectLst/>
-              <a:uFillTx/>
-              <a:latin typeface="Noto Sans"/>
+            <a:endParaRPr b="0" lang="en-IN" sz="1800" strike="noStrike" u="none">
+              <a:solidFill>
+                <a:srgbClr val="000000"/>
+              </a:solidFill>
+              <a:effectLst/>
+              <a:uFillTx/>
+              <a:latin typeface="Times New Roman"/>
             </a:endParaRPr>
           </a:p>
         </p:txBody>
@@ -698,7 +778,7 @@
         <p:spPr>
           <a:xfrm>
             <a:off x="0" y="0"/>
-            <a:ext cx="10080000" cy="5670000"/>
+            <a:ext cx="10079640" cy="5669640"/>
           </a:xfrm>
           <a:prstGeom prst="rect">
             <a:avLst/>
@@ -721,6 +801,11 @@
             <a:spAutoFit/>
           </a:bodyPr>
           <a:p>
+            <a:pPr>
+              <a:lnSpc>
+                <a:spcPct val="100000"/>
+              </a:lnSpc>
+            </a:pPr>
             <a:endParaRPr b="1" lang="en-IN" sz="1400" strike="noStrike" u="none">
               <a:solidFill>
                 <a:srgbClr val="ffffff"/>
@@ -728,6 +813,7 @@
               <a:effectLst/>
               <a:uFillTx/>
               <a:latin typeface="Noto Sans"/>
+              <a:ea typeface="DejaVu Sans"/>
             </a:endParaRPr>
           </a:p>
         </p:txBody>
@@ -741,7 +827,7 @@
         <p:spPr>
           <a:xfrm>
             <a:off x="0" y="0"/>
-            <a:ext cx="10080000" cy="3780000"/>
+            <a:ext cx="10079640" cy="3779640"/>
           </a:xfrm>
           <a:prstGeom prst="rect">
             <a:avLst/>
@@ -766,6 +852,11 @@
             <a:spAutoFit/>
           </a:bodyPr>
           <a:p>
+            <a:pPr>
+              <a:lnSpc>
+                <a:spcPct val="100000"/>
+              </a:lnSpc>
+            </a:pPr>
             <a:endParaRPr b="1" lang="en-IN" sz="1400" strike="noStrike" u="none">
               <a:solidFill>
                 <a:srgbClr val="ffffff"/>
@@ -773,6 +864,7 @@
               <a:effectLst/>
               <a:uFillTx/>
               <a:latin typeface="Noto Sans"/>
+              <a:ea typeface="DejaVu Sans"/>
             </a:endParaRPr>
           </a:p>
         </p:txBody>
@@ -790,7 +882,7 @@
         <p:spPr>
           <a:xfrm>
             <a:off x="360000" y="2835000"/>
-            <a:ext cx="9360000" cy="718920"/>
+            <a:ext cx="9359640" cy="718560"/>
           </a:xfrm>
           <a:prstGeom prst="rect">
             <a:avLst/>
@@ -806,7 +898,13 @@
           </a:bodyPr>
           <a:p>
             <a:pPr indent="0" algn="ctr">
-              <a:buNone/>
+              <a:lnSpc>
+                <a:spcPct val="100000"/>
+              </a:lnSpc>
+              <a:buNone/>
+              <a:tabLst>
+                <a:tab algn="l" pos="0"/>
+              </a:tabLst>
             </a:pPr>
             <a:r>
               <a:rPr b="1" lang="en-IN" sz="3200" strike="noStrike" u="none">
@@ -819,13 +917,13 @@
               </a:rPr>
               <a:t>Click to edit the title text format</a:t>
             </a:r>
-            <a:endParaRPr b="1" lang="en-IN" sz="3200" strike="noStrike" u="none">
-              <a:solidFill>
-                <a:srgbClr val="ffffff"/>
-              </a:solidFill>
-              <a:effectLst/>
-              <a:uFillTx/>
-              <a:latin typeface="Noto Sans"/>
+            <a:endParaRPr b="0" lang="en-IN" sz="3200" strike="noStrike" u="none">
+              <a:solidFill>
+                <a:srgbClr val="000000"/>
+              </a:solidFill>
+              <a:effectLst/>
+              <a:uFillTx/>
+              <a:latin typeface="Arial"/>
             </a:endParaRPr>
           </a:p>
         </p:txBody>
@@ -843,7 +941,7 @@
         <p:spPr>
           <a:xfrm>
             <a:off x="360000" y="3915000"/>
-            <a:ext cx="9360000" cy="1485000"/>
+            <a:ext cx="9359640" cy="1484640"/>
           </a:xfrm>
           <a:prstGeom prst="rect">
             <a:avLst/>
@@ -855,13 +953,20 @@
         </p:spPr>
         <p:txBody>
           <a:bodyPr lIns="0" rIns="0" tIns="0" bIns="0" anchor="t">
-            <a:normAutofit fontScale="77500" lnSpcReduction="19999"/>
+            <a:normAutofit fontScale="85000" lnSpcReduction="19999"/>
           </a:bodyPr>
           <a:p>
             <a:pPr marL="432000" indent="0">
+              <a:lnSpc>
+                <a:spcPct val="100000"/>
+              </a:lnSpc>
               <a:spcAft>
                 <a:spcPts val="655"/>
               </a:spcAft>
+              <a:buNone/>
+              <a:tabLst>
+                <a:tab algn="l" pos="0"/>
+              </a:tabLst>
             </a:pPr>
             <a:r>
               <a:rPr b="0" lang="en-IN" sz="1500" strike="noStrike" u="none">
@@ -876,18 +981,25 @@
             </a:r>
             <a:endParaRPr b="0" lang="en-IN" sz="1500" strike="noStrike" u="none">
               <a:solidFill>
-                <a:srgbClr val="ffffff"/>
-              </a:solidFill>
-              <a:effectLst/>
-              <a:uFillTx/>
-              <a:latin typeface="Noto Sans"/>
-            </a:endParaRPr>
-          </a:p>
-          <a:p>
-            <a:pPr lvl="1" marL="864000" indent="0">
+                <a:srgbClr val="000000"/>
+              </a:solidFill>
+              <a:effectLst/>
+              <a:uFillTx/>
+              <a:latin typeface="Arial"/>
+            </a:endParaRPr>
+          </a:p>
+          <a:p>
+            <a:pPr marL="864000" indent="0">
+              <a:lnSpc>
+                <a:spcPct val="100000"/>
+              </a:lnSpc>
               <a:spcAft>
                 <a:spcPts val="850"/>
               </a:spcAft>
+              <a:buNone/>
+              <a:tabLst>
+                <a:tab algn="l" pos="0"/>
+              </a:tabLst>
             </a:pPr>
             <a:r>
               <a:rPr b="0" lang="en-IN" sz="1500" strike="noStrike" u="none">
@@ -902,18 +1014,25 @@
             </a:r>
             <a:endParaRPr b="0" lang="en-IN" sz="1500" strike="noStrike" u="none">
               <a:solidFill>
-                <a:srgbClr val="ffffff"/>
-              </a:solidFill>
-              <a:effectLst/>
-              <a:uFillTx/>
-              <a:latin typeface="Noto Sans"/>
-            </a:endParaRPr>
-          </a:p>
-          <a:p>
-            <a:pPr lvl="2" marL="1296000" indent="0">
+                <a:srgbClr val="000000"/>
+              </a:solidFill>
+              <a:effectLst/>
+              <a:uFillTx/>
+              <a:latin typeface="Arial"/>
+            </a:endParaRPr>
+          </a:p>
+          <a:p>
+            <a:pPr marL="1296000" indent="0">
+              <a:lnSpc>
+                <a:spcPct val="100000"/>
+              </a:lnSpc>
               <a:spcAft>
                 <a:spcPts val="635"/>
               </a:spcAft>
+              <a:buNone/>
+              <a:tabLst>
+                <a:tab algn="l" pos="0"/>
+              </a:tabLst>
             </a:pPr>
             <a:r>
               <a:rPr b="0" lang="en-IN" sz="1500" strike="noStrike" u="none">
@@ -928,18 +1047,25 @@
             </a:r>
             <a:endParaRPr b="0" lang="en-IN" sz="1500" strike="noStrike" u="none">
               <a:solidFill>
-                <a:srgbClr val="ffffff"/>
-              </a:solidFill>
-              <a:effectLst/>
-              <a:uFillTx/>
-              <a:latin typeface="Noto Sans"/>
-            </a:endParaRPr>
-          </a:p>
-          <a:p>
-            <a:pPr lvl="3" marL="1728000" indent="0">
+                <a:srgbClr val="000000"/>
+              </a:solidFill>
+              <a:effectLst/>
+              <a:uFillTx/>
+              <a:latin typeface="Arial"/>
+            </a:endParaRPr>
+          </a:p>
+          <a:p>
+            <a:pPr marL="1728000" indent="0">
+              <a:lnSpc>
+                <a:spcPct val="100000"/>
+              </a:lnSpc>
               <a:spcAft>
                 <a:spcPts val="425"/>
               </a:spcAft>
+              <a:buNone/>
+              <a:tabLst>
+                <a:tab algn="l" pos="0"/>
+              </a:tabLst>
             </a:pPr>
             <a:r>
               <a:rPr b="0" lang="en-IN" sz="1500" strike="noStrike" u="none">
@@ -954,18 +1080,25 @@
             </a:r>
             <a:endParaRPr b="0" lang="en-IN" sz="1500" strike="noStrike" u="none">
               <a:solidFill>
-                <a:srgbClr val="ffffff"/>
-              </a:solidFill>
-              <a:effectLst/>
-              <a:uFillTx/>
-              <a:latin typeface="Noto Sans"/>
-            </a:endParaRPr>
-          </a:p>
-          <a:p>
-            <a:pPr lvl="4" marL="2160000" indent="0">
+                <a:srgbClr val="000000"/>
+              </a:solidFill>
+              <a:effectLst/>
+              <a:uFillTx/>
+              <a:latin typeface="Arial"/>
+            </a:endParaRPr>
+          </a:p>
+          <a:p>
+            <a:pPr marL="2160000" indent="0">
+              <a:lnSpc>
+                <a:spcPct val="100000"/>
+              </a:lnSpc>
               <a:spcAft>
                 <a:spcPts val="213"/>
               </a:spcAft>
+              <a:buNone/>
+              <a:tabLst>
+                <a:tab algn="l" pos="0"/>
+              </a:tabLst>
             </a:pPr>
             <a:r>
               <a:rPr b="0" lang="en-IN" sz="1500" strike="noStrike" u="none">
@@ -980,18 +1113,25 @@
             </a:r>
             <a:endParaRPr b="0" lang="en-IN" sz="1500" strike="noStrike" u="none">
               <a:solidFill>
-                <a:srgbClr val="ffffff"/>
-              </a:solidFill>
-              <a:effectLst/>
-              <a:uFillTx/>
-              <a:latin typeface="Noto Sans"/>
-            </a:endParaRPr>
-          </a:p>
-          <a:p>
-            <a:pPr lvl="5" marL="2592000" indent="0">
+                <a:srgbClr val="000000"/>
+              </a:solidFill>
+              <a:effectLst/>
+              <a:uFillTx/>
+              <a:latin typeface="Arial"/>
+            </a:endParaRPr>
+          </a:p>
+          <a:p>
+            <a:pPr marL="2592000" indent="0">
+              <a:lnSpc>
+                <a:spcPct val="100000"/>
+              </a:lnSpc>
               <a:spcAft>
                 <a:spcPts val="213"/>
               </a:spcAft>
+              <a:buNone/>
+              <a:tabLst>
+                <a:tab algn="l" pos="0"/>
+              </a:tabLst>
             </a:pPr>
             <a:r>
               <a:rPr b="0" lang="en-IN" sz="1500" strike="noStrike" u="none">
@@ -1006,18 +1146,25 @@
             </a:r>
             <a:endParaRPr b="0" lang="en-IN" sz="1500" strike="noStrike" u="none">
               <a:solidFill>
-                <a:srgbClr val="ffffff"/>
-              </a:solidFill>
-              <a:effectLst/>
-              <a:uFillTx/>
-              <a:latin typeface="Noto Sans"/>
-            </a:endParaRPr>
-          </a:p>
-          <a:p>
-            <a:pPr lvl="6" marL="3024000" indent="0">
+                <a:srgbClr val="000000"/>
+              </a:solidFill>
+              <a:effectLst/>
+              <a:uFillTx/>
+              <a:latin typeface="Arial"/>
+            </a:endParaRPr>
+          </a:p>
+          <a:p>
+            <a:pPr marL="3024000" indent="0">
+              <a:lnSpc>
+                <a:spcPct val="100000"/>
+              </a:lnSpc>
               <a:spcAft>
                 <a:spcPts val="213"/>
               </a:spcAft>
+              <a:buNone/>
+              <a:tabLst>
+                <a:tab algn="l" pos="0"/>
+              </a:tabLst>
             </a:pPr>
             <a:r>
               <a:rPr b="0" lang="en-IN" sz="1500" strike="noStrike" u="none">
@@ -1032,11 +1179,11 @@
             </a:r>
             <a:endParaRPr b="0" lang="en-IN" sz="1500" strike="noStrike" u="none">
               <a:solidFill>
-                <a:srgbClr val="ffffff"/>
-              </a:solidFill>
-              <a:effectLst/>
-              <a:uFillTx/>
-              <a:latin typeface="Noto Sans"/>
+                <a:srgbClr val="000000"/>
+              </a:solidFill>
+              <a:effectLst/>
+              <a:uFillTx/>
+              <a:latin typeface="Arial"/>
             </a:endParaRPr>
           </a:p>
         </p:txBody>
@@ -1054,7 +1201,7 @@
         <p:spPr>
           <a:xfrm>
             <a:off x="360000" y="5400000"/>
-            <a:ext cx="2880000" cy="311400"/>
+            <a:ext cx="2879640" cy="311400"/>
           </a:xfrm>
           <a:prstGeom prst="rect">
             <a:avLst/>
@@ -1070,7 +1217,13 @@
           </a:bodyPr>
           <a:lstStyle>
             <a:lvl1pPr indent="0">
-              <a:buNone/>
+              <a:lnSpc>
+                <a:spcPct val="100000"/>
+              </a:lnSpc>
+              <a:buNone/>
+              <a:tabLst>
+                <a:tab algn="l" pos="0"/>
+              </a:tabLst>
               <a:defRPr b="1" lang="en-IN" sz="1800" strike="noStrike" u="none">
                 <a:solidFill>
                   <a:srgbClr val="ffffff"/>
@@ -1083,7 +1236,13 @@
           </a:lstStyle>
           <a:p>
             <a:pPr indent="0">
-              <a:buNone/>
+              <a:lnSpc>
+                <a:spcPct val="100000"/>
+              </a:lnSpc>
+              <a:buNone/>
+              <a:tabLst>
+                <a:tab algn="l" pos="0"/>
+              </a:tabLst>
             </a:pPr>
             <a:r>
               <a:rPr b="1" lang="en-IN" sz="1800" strike="noStrike" u="none">
@@ -1096,13 +1255,13 @@
               </a:rPr>
               <a:t>&lt;date/time&gt;</a:t>
             </a:r>
-            <a:endParaRPr b="1" lang="en-IN" sz="1800" strike="noStrike" u="none">
-              <a:solidFill>
-                <a:srgbClr val="ffffff"/>
-              </a:solidFill>
-              <a:effectLst/>
-              <a:uFillTx/>
-              <a:latin typeface="Noto Sans"/>
+            <a:endParaRPr b="0" lang="en-IN" sz="1800" strike="noStrike" u="none">
+              <a:solidFill>
+                <a:srgbClr val="000000"/>
+              </a:solidFill>
+              <a:effectLst/>
+              <a:uFillTx/>
+              <a:latin typeface="Times New Roman"/>
             </a:endParaRPr>
           </a:p>
         </p:txBody>
@@ -1120,7 +1279,7 @@
         <p:spPr>
           <a:xfrm>
             <a:off x="3420000" y="5400000"/>
-            <a:ext cx="3240000" cy="311400"/>
+            <a:ext cx="3239640" cy="311400"/>
           </a:xfrm>
           <a:prstGeom prst="rect">
             <a:avLst/>
@@ -1136,7 +1295,13 @@
           </a:bodyPr>
           <a:lstStyle>
             <a:lvl1pPr indent="0" algn="ctr">
-              <a:buNone/>
+              <a:lnSpc>
+                <a:spcPct val="100000"/>
+              </a:lnSpc>
+              <a:buNone/>
+              <a:tabLst>
+                <a:tab algn="l" pos="0"/>
+              </a:tabLst>
               <a:defRPr b="1" lang="en-IN" sz="1800" strike="noStrike" u="none">
                 <a:solidFill>
                   <a:srgbClr val="ffffff"/>
@@ -1149,7 +1314,13 @@
           </a:lstStyle>
           <a:p>
             <a:pPr indent="0" algn="ctr">
-              <a:buNone/>
+              <a:lnSpc>
+                <a:spcPct val="100000"/>
+              </a:lnSpc>
+              <a:buNone/>
+              <a:tabLst>
+                <a:tab algn="l" pos="0"/>
+              </a:tabLst>
             </a:pPr>
             <a:r>
               <a:rPr b="1" lang="en-IN" sz="1800" strike="noStrike" u="none">
@@ -1162,13 +1333,13 @@
               </a:rPr>
               <a:t>&lt;footer&gt;</a:t>
             </a:r>
-            <a:endParaRPr b="1" lang="en-IN" sz="1800" strike="noStrike" u="none">
-              <a:solidFill>
-                <a:srgbClr val="ffffff"/>
-              </a:solidFill>
-              <a:effectLst/>
-              <a:uFillTx/>
-              <a:latin typeface="Noto Sans"/>
+            <a:endParaRPr b="0" lang="en-IN" sz="1800" strike="noStrike" u="none">
+              <a:solidFill>
+                <a:srgbClr val="000000"/>
+              </a:solidFill>
+              <a:effectLst/>
+              <a:uFillTx/>
+              <a:latin typeface="Times New Roman"/>
             </a:endParaRPr>
           </a:p>
         </p:txBody>
@@ -1185,8 +1356,8 @@
         </p:nvSpPr>
         <p:spPr>
           <a:xfrm>
-            <a:off x="9180000" y="5130000"/>
-            <a:ext cx="720000" cy="540000"/>
+            <a:off x="9180000" y="5262480"/>
+            <a:ext cx="719640" cy="274680"/>
           </a:xfrm>
           <a:prstGeom prst="rect">
             <a:avLst/>
@@ -1202,7 +1373,13 @@
           </a:bodyPr>
           <a:lstStyle>
             <a:lvl1pPr indent="0" algn="ctr">
-              <a:buNone/>
+              <a:lnSpc>
+                <a:spcPct val="100000"/>
+              </a:lnSpc>
+              <a:buNone/>
+              <a:tabLst>
+                <a:tab algn="l" pos="0"/>
+              </a:tabLst>
               <a:defRPr b="1" lang="en-IN" sz="1800" strike="noStrike" u="none">
                 <a:solidFill>
                   <a:srgbClr val="ffffff"/>
@@ -1215,9 +1392,15 @@
           </a:lstStyle>
           <a:p>
             <a:pPr indent="0" algn="ctr">
-              <a:buNone/>
-            </a:pPr>
-            <a:fld id="{55D10D95-5B4F-4DBB-821A-6E47105C6489}" type="slidenum">
+              <a:lnSpc>
+                <a:spcPct val="100000"/>
+              </a:lnSpc>
+              <a:buNone/>
+              <a:tabLst>
+                <a:tab algn="l" pos="0"/>
+              </a:tabLst>
+            </a:pPr>
+            <a:fld id="{79A9D5CF-2578-4E09-BE74-2FC321F4CF68}" type="slidenum">
               <a:rPr b="1" lang="en-IN" sz="1800" strike="noStrike" u="none">
                 <a:solidFill>
                   <a:srgbClr val="ffffff"/>
@@ -1228,13 +1411,13 @@
               </a:rPr>
               <a:t>&lt;number&gt;</a:t>
             </a:fld>
-            <a:endParaRPr b="1" lang="en-IN" sz="1800" strike="noStrike" u="none">
-              <a:solidFill>
-                <a:srgbClr val="ffffff"/>
-              </a:solidFill>
-              <a:effectLst/>
-              <a:uFillTx/>
-              <a:latin typeface="Noto Sans"/>
+            <a:endParaRPr b="0" lang="en-IN" sz="1800" strike="noStrike" u="none">
+              <a:solidFill>
+                <a:srgbClr val="000000"/>
+              </a:solidFill>
+              <a:effectLst/>
+              <a:uFillTx/>
+              <a:latin typeface="Times New Roman"/>
             </a:endParaRPr>
           </a:p>
         </p:txBody>
@@ -1270,7 +1453,7 @@
         <p:spPr>
           <a:xfrm>
             <a:off x="0" y="0"/>
-            <a:ext cx="10080000" cy="5670000"/>
+            <a:ext cx="10079640" cy="5669640"/>
           </a:xfrm>
           <a:prstGeom prst="rect">
             <a:avLst/>
@@ -1293,6 +1476,11 @@
             <a:spAutoFit/>
           </a:bodyPr>
           <a:p>
+            <a:pPr>
+              <a:lnSpc>
+                <a:spcPct val="100000"/>
+              </a:lnSpc>
+            </a:pPr>
             <a:endParaRPr b="1" lang="en-IN" sz="1400" strike="noStrike" u="none">
               <a:solidFill>
                 <a:srgbClr val="ffffff"/>
@@ -1300,6 +1488,7 @@
               <a:effectLst/>
               <a:uFillTx/>
               <a:latin typeface="Noto Sans"/>
+              <a:ea typeface="DejaVu Sans"/>
             </a:endParaRPr>
           </a:p>
         </p:txBody>
@@ -1313,7 +1502,7 @@
         <p:spPr>
           <a:xfrm>
             <a:off x="2520000" y="1350000"/>
-            <a:ext cx="5040000" cy="1890000"/>
+            <a:ext cx="5039640" cy="1889640"/>
           </a:xfrm>
           <a:prstGeom prst="wedgeRectCallout">
             <a:avLst>
@@ -1342,6 +1531,11 @@
             <a:noAutofit/>
           </a:bodyPr>
           <a:p>
+            <a:pPr>
+              <a:lnSpc>
+                <a:spcPct val="100000"/>
+              </a:lnSpc>
+            </a:pPr>
             <a:endParaRPr b="1" lang="en-IN" sz="1400" strike="noStrike" u="none">
               <a:solidFill>
                 <a:srgbClr val="2c3e50"/>
@@ -1349,6 +1543,7 @@
               <a:effectLst/>
               <a:uFillTx/>
               <a:latin typeface="Noto Sans"/>
+              <a:ea typeface="DejaVu Sans"/>
             </a:endParaRPr>
           </a:p>
         </p:txBody>
@@ -1366,7 +1561,7 @@
         <p:spPr>
           <a:xfrm>
             <a:off x="2700000" y="1485000"/>
-            <a:ext cx="4680000" cy="1620000"/>
+            <a:ext cx="4679640" cy="1619640"/>
           </a:xfrm>
           <a:prstGeom prst="rect">
             <a:avLst/>
@@ -1382,7 +1577,13 @@
           </a:bodyPr>
           <a:p>
             <a:pPr indent="0" algn="ctr">
-              <a:buNone/>
+              <a:lnSpc>
+                <a:spcPct val="100000"/>
+              </a:lnSpc>
+              <a:buNone/>
+              <a:tabLst>
+                <a:tab algn="l" pos="0"/>
+              </a:tabLst>
             </a:pPr>
             <a:r>
               <a:rPr b="1" lang="en-IN" sz="2700" strike="noStrike" u="none">
@@ -1395,13 +1596,13 @@
               </a:rPr>
               <a:t>Click to edit the title text format</a:t>
             </a:r>
-            <a:endParaRPr b="1" lang="en-IN" sz="2700" strike="noStrike" u="none">
-              <a:solidFill>
-                <a:srgbClr val="2c3e50"/>
-              </a:solidFill>
-              <a:effectLst/>
-              <a:uFillTx/>
-              <a:latin typeface="Noto Sans"/>
+            <a:endParaRPr b="0" lang="en-IN" sz="2700" strike="noStrike" u="none">
+              <a:solidFill>
+                <a:srgbClr val="000000"/>
+              </a:solidFill>
+              <a:effectLst/>
+              <a:uFillTx/>
+              <a:latin typeface="Arial"/>
             </a:endParaRPr>
           </a:p>
         </p:txBody>
@@ -1419,7 +1620,7 @@
         <p:spPr>
           <a:xfrm>
             <a:off x="3420000" y="3240000"/>
-            <a:ext cx="6300000" cy="1620000"/>
+            <a:ext cx="6299640" cy="1619640"/>
           </a:xfrm>
           <a:prstGeom prst="rect">
             <a:avLst/>
@@ -1431,13 +1632,20 @@
         </p:spPr>
         <p:txBody>
           <a:bodyPr lIns="0" rIns="0" tIns="0" bIns="0" anchor="t">
-            <a:normAutofit fontScale="85000" lnSpcReduction="19999"/>
+            <a:normAutofit fontScale="92500" lnSpcReduction="19999"/>
           </a:bodyPr>
           <a:p>
             <a:pPr marL="432000" indent="0">
+              <a:lnSpc>
+                <a:spcPct val="100000"/>
+              </a:lnSpc>
               <a:spcAft>
                 <a:spcPts val="655"/>
               </a:spcAft>
+              <a:buNone/>
+              <a:tabLst>
+                <a:tab algn="l" pos="0"/>
+              </a:tabLst>
             </a:pPr>
             <a:r>
               <a:rPr b="0" lang="en-IN" sz="1500" strike="noStrike" u="none">
@@ -1452,18 +1660,25 @@
             </a:r>
             <a:endParaRPr b="0" lang="en-IN" sz="1500" strike="noStrike" u="none">
               <a:solidFill>
-                <a:srgbClr val="ffffff"/>
-              </a:solidFill>
-              <a:effectLst/>
-              <a:uFillTx/>
-              <a:latin typeface="Noto Sans"/>
-            </a:endParaRPr>
-          </a:p>
-          <a:p>
-            <a:pPr lvl="1" marL="864000" indent="0">
+                <a:srgbClr val="000000"/>
+              </a:solidFill>
+              <a:effectLst/>
+              <a:uFillTx/>
+              <a:latin typeface="Arial"/>
+            </a:endParaRPr>
+          </a:p>
+          <a:p>
+            <a:pPr marL="864000" indent="0">
+              <a:lnSpc>
+                <a:spcPct val="100000"/>
+              </a:lnSpc>
               <a:spcAft>
                 <a:spcPts val="850"/>
               </a:spcAft>
+              <a:buNone/>
+              <a:tabLst>
+                <a:tab algn="l" pos="0"/>
+              </a:tabLst>
             </a:pPr>
             <a:r>
               <a:rPr b="0" lang="en-IN" sz="1500" strike="noStrike" u="none">
@@ -1478,18 +1693,25 @@
             </a:r>
             <a:endParaRPr b="0" lang="en-IN" sz="1500" strike="noStrike" u="none">
               <a:solidFill>
-                <a:srgbClr val="ffffff"/>
-              </a:solidFill>
-              <a:effectLst/>
-              <a:uFillTx/>
-              <a:latin typeface="Noto Sans"/>
-            </a:endParaRPr>
-          </a:p>
-          <a:p>
-            <a:pPr lvl="2" marL="1296000" indent="0">
+                <a:srgbClr val="000000"/>
+              </a:solidFill>
+              <a:effectLst/>
+              <a:uFillTx/>
+              <a:latin typeface="Arial"/>
+            </a:endParaRPr>
+          </a:p>
+          <a:p>
+            <a:pPr marL="1296000" indent="0">
+              <a:lnSpc>
+                <a:spcPct val="100000"/>
+              </a:lnSpc>
               <a:spcAft>
                 <a:spcPts val="635"/>
               </a:spcAft>
+              <a:buNone/>
+              <a:tabLst>
+                <a:tab algn="l" pos="0"/>
+              </a:tabLst>
             </a:pPr>
             <a:r>
               <a:rPr b="0" lang="en-IN" sz="1500" strike="noStrike" u="none">
@@ -1504,18 +1726,25 @@
             </a:r>
             <a:endParaRPr b="0" lang="en-IN" sz="1500" strike="noStrike" u="none">
               <a:solidFill>
-                <a:srgbClr val="ffffff"/>
-              </a:solidFill>
-              <a:effectLst/>
-              <a:uFillTx/>
-              <a:latin typeface="Noto Sans"/>
-            </a:endParaRPr>
-          </a:p>
-          <a:p>
-            <a:pPr lvl="3" marL="1728000" indent="0">
+                <a:srgbClr val="000000"/>
+              </a:solidFill>
+              <a:effectLst/>
+              <a:uFillTx/>
+              <a:latin typeface="Arial"/>
+            </a:endParaRPr>
+          </a:p>
+          <a:p>
+            <a:pPr marL="1728000" indent="0">
+              <a:lnSpc>
+                <a:spcPct val="100000"/>
+              </a:lnSpc>
               <a:spcAft>
                 <a:spcPts val="425"/>
               </a:spcAft>
+              <a:buNone/>
+              <a:tabLst>
+                <a:tab algn="l" pos="0"/>
+              </a:tabLst>
             </a:pPr>
             <a:r>
               <a:rPr b="0" lang="en-IN" sz="1500" strike="noStrike" u="none">
@@ -1530,18 +1759,25 @@
             </a:r>
             <a:endParaRPr b="0" lang="en-IN" sz="1500" strike="noStrike" u="none">
               <a:solidFill>
-                <a:srgbClr val="ffffff"/>
-              </a:solidFill>
-              <a:effectLst/>
-              <a:uFillTx/>
-              <a:latin typeface="Noto Sans"/>
-            </a:endParaRPr>
-          </a:p>
-          <a:p>
-            <a:pPr lvl="4" marL="2160000" indent="0">
+                <a:srgbClr val="000000"/>
+              </a:solidFill>
+              <a:effectLst/>
+              <a:uFillTx/>
+              <a:latin typeface="Arial"/>
+            </a:endParaRPr>
+          </a:p>
+          <a:p>
+            <a:pPr marL="2160000" indent="0">
+              <a:lnSpc>
+                <a:spcPct val="100000"/>
+              </a:lnSpc>
               <a:spcAft>
                 <a:spcPts val="213"/>
               </a:spcAft>
+              <a:buNone/>
+              <a:tabLst>
+                <a:tab algn="l" pos="0"/>
+              </a:tabLst>
             </a:pPr>
             <a:r>
               <a:rPr b="0" lang="en-IN" sz="1500" strike="noStrike" u="none">
@@ -1556,18 +1792,25 @@
             </a:r>
             <a:endParaRPr b="0" lang="en-IN" sz="1500" strike="noStrike" u="none">
               <a:solidFill>
-                <a:srgbClr val="ffffff"/>
-              </a:solidFill>
-              <a:effectLst/>
-              <a:uFillTx/>
-              <a:latin typeface="Noto Sans"/>
-            </a:endParaRPr>
-          </a:p>
-          <a:p>
-            <a:pPr lvl="5" marL="2592000" indent="0">
+                <a:srgbClr val="000000"/>
+              </a:solidFill>
+              <a:effectLst/>
+              <a:uFillTx/>
+              <a:latin typeface="Arial"/>
+            </a:endParaRPr>
+          </a:p>
+          <a:p>
+            <a:pPr marL="2592000" indent="0">
+              <a:lnSpc>
+                <a:spcPct val="100000"/>
+              </a:lnSpc>
               <a:spcAft>
                 <a:spcPts val="213"/>
               </a:spcAft>
+              <a:buNone/>
+              <a:tabLst>
+                <a:tab algn="l" pos="0"/>
+              </a:tabLst>
             </a:pPr>
             <a:r>
               <a:rPr b="0" lang="en-IN" sz="1500" strike="noStrike" u="none">
@@ -1582,18 +1825,25 @@
             </a:r>
             <a:endParaRPr b="0" lang="en-IN" sz="1500" strike="noStrike" u="none">
               <a:solidFill>
-                <a:srgbClr val="ffffff"/>
-              </a:solidFill>
-              <a:effectLst/>
-              <a:uFillTx/>
-              <a:latin typeface="Noto Sans"/>
-            </a:endParaRPr>
-          </a:p>
-          <a:p>
-            <a:pPr lvl="6" marL="3024000" indent="0">
+                <a:srgbClr val="000000"/>
+              </a:solidFill>
+              <a:effectLst/>
+              <a:uFillTx/>
+              <a:latin typeface="Arial"/>
+            </a:endParaRPr>
+          </a:p>
+          <a:p>
+            <a:pPr marL="3024000" indent="0">
+              <a:lnSpc>
+                <a:spcPct val="100000"/>
+              </a:lnSpc>
               <a:spcAft>
                 <a:spcPts val="213"/>
               </a:spcAft>
+              <a:buNone/>
+              <a:tabLst>
+                <a:tab algn="l" pos="0"/>
+              </a:tabLst>
             </a:pPr>
             <a:r>
               <a:rPr b="0" lang="en-IN" sz="1500" strike="noStrike" u="none">
@@ -1608,11 +1858,11 @@
             </a:r>
             <a:endParaRPr b="0" lang="en-IN" sz="1500" strike="noStrike" u="none">
               <a:solidFill>
-                <a:srgbClr val="ffffff"/>
-              </a:solidFill>
-              <a:effectLst/>
-              <a:uFillTx/>
-              <a:latin typeface="Noto Sans"/>
+                <a:srgbClr val="000000"/>
+              </a:solidFill>
+              <a:effectLst/>
+              <a:uFillTx/>
+              <a:latin typeface="Arial"/>
             </a:endParaRPr>
           </a:p>
         </p:txBody>
@@ -1630,7 +1880,7 @@
         <p:spPr>
           <a:xfrm>
             <a:off x="360000" y="5400000"/>
-            <a:ext cx="2880000" cy="311400"/>
+            <a:ext cx="2879640" cy="311400"/>
           </a:xfrm>
           <a:prstGeom prst="rect">
             <a:avLst/>
@@ -1646,7 +1896,13 @@
           </a:bodyPr>
           <a:lstStyle>
             <a:lvl1pPr indent="0">
-              <a:buNone/>
+              <a:lnSpc>
+                <a:spcPct val="100000"/>
+              </a:lnSpc>
+              <a:buNone/>
+              <a:tabLst>
+                <a:tab algn="l" pos="0"/>
+              </a:tabLst>
               <a:defRPr b="1" lang="en-IN" sz="1800" strike="noStrike" u="none">
                 <a:solidFill>
                   <a:srgbClr val="ffffff"/>
@@ -1659,7 +1915,13 @@
           </a:lstStyle>
           <a:p>
             <a:pPr indent="0">
-              <a:buNone/>
+              <a:lnSpc>
+                <a:spcPct val="100000"/>
+              </a:lnSpc>
+              <a:buNone/>
+              <a:tabLst>
+                <a:tab algn="l" pos="0"/>
+              </a:tabLst>
             </a:pPr>
             <a:r>
               <a:rPr b="1" lang="en-IN" sz="1800" strike="noStrike" u="none">
@@ -1672,13 +1934,13 @@
               </a:rPr>
               <a:t>&lt;date/time&gt;</a:t>
             </a:r>
-            <a:endParaRPr b="1" lang="en-IN" sz="1800" strike="noStrike" u="none">
-              <a:solidFill>
-                <a:srgbClr val="ffffff"/>
-              </a:solidFill>
-              <a:effectLst/>
-              <a:uFillTx/>
-              <a:latin typeface="Noto Sans"/>
+            <a:endParaRPr b="0" lang="en-IN" sz="1800" strike="noStrike" u="none">
+              <a:solidFill>
+                <a:srgbClr val="000000"/>
+              </a:solidFill>
+              <a:effectLst/>
+              <a:uFillTx/>
+              <a:latin typeface="Times New Roman"/>
             </a:endParaRPr>
           </a:p>
         </p:txBody>
@@ -1696,7 +1958,7 @@
         <p:spPr>
           <a:xfrm>
             <a:off x="3420000" y="5400000"/>
-            <a:ext cx="3240000" cy="311400"/>
+            <a:ext cx="3239640" cy="311400"/>
           </a:xfrm>
           <a:prstGeom prst="rect">
             <a:avLst/>
@@ -1712,7 +1974,13 @@
           </a:bodyPr>
           <a:lstStyle>
             <a:lvl1pPr indent="0" algn="ctr">
-              <a:buNone/>
+              <a:lnSpc>
+                <a:spcPct val="100000"/>
+              </a:lnSpc>
+              <a:buNone/>
+              <a:tabLst>
+                <a:tab algn="l" pos="0"/>
+              </a:tabLst>
               <a:defRPr b="1" lang="en-IN" sz="1800" strike="noStrike" u="none">
                 <a:solidFill>
                   <a:srgbClr val="ffffff"/>
@@ -1725,7 +1993,13 @@
           </a:lstStyle>
           <a:p>
             <a:pPr indent="0" algn="ctr">
-              <a:buNone/>
+              <a:lnSpc>
+                <a:spcPct val="100000"/>
+              </a:lnSpc>
+              <a:buNone/>
+              <a:tabLst>
+                <a:tab algn="l" pos="0"/>
+              </a:tabLst>
             </a:pPr>
             <a:r>
               <a:rPr b="1" lang="en-IN" sz="1800" strike="noStrike" u="none">
@@ -1738,13 +2012,13 @@
               </a:rPr>
               <a:t>&lt;footer&gt;</a:t>
             </a:r>
-            <a:endParaRPr b="1" lang="en-IN" sz="1800" strike="noStrike" u="none">
-              <a:solidFill>
-                <a:srgbClr val="ffffff"/>
-              </a:solidFill>
-              <a:effectLst/>
-              <a:uFillTx/>
-              <a:latin typeface="Noto Sans"/>
+            <a:endParaRPr b="0" lang="en-IN" sz="1800" strike="noStrike" u="none">
+              <a:solidFill>
+                <a:srgbClr val="000000"/>
+              </a:solidFill>
+              <a:effectLst/>
+              <a:uFillTx/>
+              <a:latin typeface="Times New Roman"/>
             </a:endParaRPr>
           </a:p>
         </p:txBody>
@@ -1761,8 +2035,8 @@
         </p:nvSpPr>
         <p:spPr>
           <a:xfrm>
-            <a:off x="9180000" y="5130000"/>
-            <a:ext cx="720000" cy="540000"/>
+            <a:off x="9180000" y="5262480"/>
+            <a:ext cx="719640" cy="274680"/>
           </a:xfrm>
           <a:prstGeom prst="rect">
             <a:avLst/>
@@ -1778,7 +2052,13 @@
           </a:bodyPr>
           <a:lstStyle>
             <a:lvl1pPr indent="0" algn="ctr">
-              <a:buNone/>
+              <a:lnSpc>
+                <a:spcPct val="100000"/>
+              </a:lnSpc>
+              <a:buNone/>
+              <a:tabLst>
+                <a:tab algn="l" pos="0"/>
+              </a:tabLst>
               <a:defRPr b="1" lang="en-IN" sz="1800" strike="noStrike" u="none">
                 <a:solidFill>
                   <a:srgbClr val="ffffff"/>
@@ -1791,9 +2071,15 @@
           </a:lstStyle>
           <a:p>
             <a:pPr indent="0" algn="ctr">
-              <a:buNone/>
-            </a:pPr>
-            <a:fld id="{792DAF30-BD0B-4B32-84A7-617DAF507706}" type="slidenum">
+              <a:lnSpc>
+                <a:spcPct val="100000"/>
+              </a:lnSpc>
+              <a:buNone/>
+              <a:tabLst>
+                <a:tab algn="l" pos="0"/>
+              </a:tabLst>
+            </a:pPr>
+            <a:fld id="{5DD32AE4-C3A7-40D3-BDA4-4F8D23F591CD}" type="slidenum">
               <a:rPr b="1" lang="en-IN" sz="1800" strike="noStrike" u="none">
                 <a:solidFill>
                   <a:srgbClr val="ffffff"/>
@@ -1804,13 +2090,13 @@
               </a:rPr>
               <a:t>&lt;number&gt;</a:t>
             </a:fld>
-            <a:endParaRPr b="1" lang="en-IN" sz="1800" strike="noStrike" u="none">
-              <a:solidFill>
-                <a:srgbClr val="ffffff"/>
-              </a:solidFill>
-              <a:effectLst/>
-              <a:uFillTx/>
-              <a:latin typeface="Noto Sans"/>
+            <a:endParaRPr b="0" lang="en-IN" sz="1800" strike="noStrike" u="none">
+              <a:solidFill>
+                <a:srgbClr val="000000"/>
+              </a:solidFill>
+              <a:effectLst/>
+              <a:uFillTx/>
+              <a:latin typeface="Times New Roman"/>
             </a:endParaRPr>
           </a:p>
         </p:txBody>
@@ -1878,7 +2164,7 @@
         <p:spPr>
           <a:xfrm>
             <a:off x="360000" y="225720"/>
-            <a:ext cx="9360000" cy="720000"/>
+            <a:ext cx="9359640" cy="719640"/>
           </a:xfrm>
           <a:prstGeom prst="rect">
             <a:avLst/>
@@ -1894,7 +2180,13 @@
           </a:bodyPr>
           <a:p>
             <a:pPr indent="0">
-              <a:buNone/>
+              <a:lnSpc>
+                <a:spcPct val="100000"/>
+              </a:lnSpc>
+              <a:buNone/>
+              <a:tabLst>
+                <a:tab algn="l" pos="0"/>
+              </a:tabLst>
             </a:pPr>
             <a:r>
               <a:rPr b="1" lang="en-IN" sz="6000" strike="noStrike" u="none">
@@ -1905,197 +2197,29 @@
                 <a:uFillTx/>
                 <a:latin typeface="Noto Sans"/>
               </a:rPr>
-              <a:t>PROBLEM </a:t>
-            </a:r>
-            <a:r>
-              <a:rPr b="1" lang="en-IN" sz="4200" strike="noStrike" u="none">
-                <a:solidFill>
-                  <a:srgbClr val="ffffff"/>
-                </a:solidFill>
-                <a:effectLst/>
-                <a:uFillTx/>
-                <a:latin typeface="Noto Sans"/>
-              </a:rPr>
-              <a:t>(Help Principal)</a:t>
-            </a:r>
-            <a:endParaRPr b="1" lang="en-IN" sz="4200" strike="noStrike" u="none">
-              <a:solidFill>
-                <a:srgbClr val="ffffff"/>
-              </a:solidFill>
-              <a:effectLst/>
-              <a:uFillTx/>
-              <a:latin typeface="Noto Sans"/>
+              <a:t>DATA COMMUNICATION</a:t>
+            </a:r>
+            <a:endParaRPr b="0" lang="en-IN" sz="6000" strike="noStrike" u="none">
+              <a:solidFill>
+                <a:srgbClr val="000000"/>
+              </a:solidFill>
+              <a:effectLst/>
+              <a:uFillTx/>
+              <a:latin typeface="Arial"/>
             </a:endParaRPr>
           </a:p>
         </p:txBody>
       </p:sp>
       <p:sp>
         <p:nvSpPr>
-          <p:cNvPr id="23" name="PlaceHolder 2"/>
-          <p:cNvSpPr>
-            <a:spLocks noGrp="1"/>
-          </p:cNvSpPr>
-          <p:nvPr>
-            <p:ph/>
-          </p:nvPr>
-        </p:nvSpPr>
-        <p:spPr>
-          <a:xfrm>
-            <a:off x="360000" y="1485000"/>
-            <a:ext cx="9360000" cy="2655000"/>
-          </a:xfrm>
-          <a:prstGeom prst="rect">
-            <a:avLst/>
-          </a:prstGeom>
-          <a:noFill/>
-          <a:ln w="0">
-            <a:noFill/>
-          </a:ln>
-        </p:spPr>
-        <p:txBody>
-          <a:bodyPr lIns="0" rIns="0" tIns="0" bIns="0" anchor="t">
-            <a:normAutofit/>
-          </a:bodyPr>
-          <a:p>
-            <a:pPr marL="432000" indent="-324000">
-              <a:spcAft>
-                <a:spcPts val="1057"/>
-              </a:spcAft>
-              <a:buClr>
-                <a:srgbClr val="2c3e50"/>
-              </a:buClr>
-              <a:buSzPct val="45000"/>
-              <a:buFont typeface="Wingdings" charset="2"/>
-              <a:buChar char=""/>
-            </a:pPr>
-            <a:r>
-              <a:rPr b="1" lang="en-IN" sz="2800" strike="noStrike" u="none">
-                <a:solidFill>
-                  <a:srgbClr val="2c3e50"/>
-                </a:solidFill>
-                <a:effectLst/>
-                <a:uFillTx/>
-                <a:latin typeface="Noto Sans"/>
-              </a:rPr>
-              <a:t>Which student has the highest average marks?</a:t>
-            </a:r>
-            <a:endParaRPr b="1" lang="en-IN" sz="2800" strike="noStrike" u="none">
-              <a:solidFill>
-                <a:srgbClr val="2c3e50"/>
-              </a:solidFill>
-              <a:effectLst/>
-              <a:uFillTx/>
-              <a:latin typeface="Noto Sans"/>
-            </a:endParaRPr>
-          </a:p>
-          <a:p>
-            <a:pPr marL="432000" indent="-324000">
-              <a:spcAft>
-                <a:spcPts val="1057"/>
-              </a:spcAft>
-              <a:buClr>
-                <a:srgbClr val="2c3e50"/>
-              </a:buClr>
-              <a:buSzPct val="45000"/>
-              <a:buFont typeface="Wingdings" charset="2"/>
-              <a:buChar char=""/>
-            </a:pPr>
-            <a:r>
-              <a:rPr b="1" lang="en-IN" sz="2800" strike="noStrike" u="none">
-                <a:solidFill>
-                  <a:srgbClr val="2c3e50"/>
-                </a:solidFill>
-                <a:effectLst/>
-                <a:uFillTx/>
-                <a:latin typeface="Noto Sans"/>
-              </a:rPr>
-              <a:t>Which students scored above 90?</a:t>
-            </a:r>
-            <a:endParaRPr b="1" lang="en-IN" sz="2800" strike="noStrike" u="none">
-              <a:solidFill>
-                <a:srgbClr val="2c3e50"/>
-              </a:solidFill>
-              <a:effectLst/>
-              <a:uFillTx/>
-              <a:latin typeface="Noto Sans"/>
-            </a:endParaRPr>
-          </a:p>
-          <a:p>
-            <a:pPr marL="432000" indent="-324000">
-              <a:spcAft>
-                <a:spcPts val="1057"/>
-              </a:spcAft>
-              <a:buClr>
-                <a:srgbClr val="2c3e50"/>
-              </a:buClr>
-              <a:buSzPct val="45000"/>
-              <a:buFont typeface="Wingdings" charset="2"/>
-              <a:buChar char=""/>
-            </a:pPr>
-            <a:r>
-              <a:rPr b="1" lang="en-IN" sz="2800" strike="noStrike" u="none">
-                <a:solidFill>
-                  <a:srgbClr val="2c3e50"/>
-                </a:solidFill>
-                <a:effectLst/>
-                <a:uFillTx/>
-                <a:latin typeface="Noto Sans"/>
-              </a:rPr>
-              <a:t>How are marks distributed?</a:t>
-            </a:r>
-            <a:endParaRPr b="1" lang="en-IN" sz="2800" strike="noStrike" u="none">
-              <a:solidFill>
-                <a:srgbClr val="2c3e50"/>
-              </a:solidFill>
-              <a:effectLst/>
-              <a:uFillTx/>
-              <a:latin typeface="Noto Sans"/>
-            </a:endParaRPr>
-          </a:p>
-          <a:p>
-            <a:pPr marL="432000" indent="-324000">
-              <a:spcAft>
-                <a:spcPts val="1057"/>
-              </a:spcAft>
-              <a:buClr>
-                <a:srgbClr val="2c3e50"/>
-              </a:buClr>
-              <a:buSzPct val="45000"/>
-              <a:buFont typeface="Wingdings" charset="2"/>
-              <a:buChar char=""/>
-            </a:pPr>
-            <a:r>
-              <a:rPr b="1" lang="en-IN" sz="2800" strike="noStrike" u="none">
-                <a:solidFill>
-                  <a:srgbClr val="2c3e50"/>
-                </a:solidFill>
-                <a:effectLst/>
-                <a:uFillTx/>
-                <a:latin typeface="Noto Sans"/>
-              </a:rPr>
-              <a:t>Which subject needs improvement?</a:t>
-            </a:r>
-            <a:endParaRPr b="1" lang="en-IN" sz="2800" strike="noStrike" u="none">
-              <a:solidFill>
-                <a:srgbClr val="2c3e50"/>
-              </a:solidFill>
-              <a:effectLst/>
-              <a:uFillTx/>
-              <a:latin typeface="Noto Sans"/>
-            </a:endParaRPr>
-          </a:p>
-        </p:txBody>
-      </p:sp>
-      <p:sp>
-        <p:nvSpPr>
-          <p:cNvPr id="24" name=""/>
+          <p:cNvPr id="23" name=""/>
           <p:cNvSpPr/>
           <p:nvPr/>
         </p:nvSpPr>
         <p:spPr>
           <a:xfrm>
             <a:off x="360000" y="4860000"/>
-            <a:ext cx="3600000" cy="540000"/>
+            <a:ext cx="3599640" cy="539640"/>
           </a:xfrm>
           <a:prstGeom prst="flowChartAlternateProcess">
             <a:avLst/>
@@ -2134,16 +2258,425 @@
                 <a:effectLst/>
                 <a:uFillTx/>
                 <a:latin typeface="Noto Sans"/>
+                <a:ea typeface="DejaVu Sans"/>
               </a:rPr>
               <a:t>youtube.com/@ssutradhar35</a:t>
             </a:r>
             <a:endParaRPr b="0" lang="en-IN" sz="1800" strike="noStrike" u="none">
               <a:solidFill>
+                <a:srgbClr val="ffffff"/>
+              </a:solidFill>
+              <a:effectLst/>
+              <a:uFillTx/>
+              <a:latin typeface="Arial"/>
+            </a:endParaRPr>
+          </a:p>
+        </p:txBody>
+      </p:sp>
+      <p:sp>
+        <p:nvSpPr>
+          <p:cNvPr id="24" name=""/>
+          <p:cNvSpPr/>
+          <p:nvPr/>
+        </p:nvSpPr>
+        <p:spPr>
+          <a:xfrm>
+            <a:off x="720000" y="2224800"/>
+            <a:ext cx="8639640" cy="1309680"/>
+          </a:xfrm>
+          <a:prstGeom prst="rect">
+            <a:avLst/>
+          </a:prstGeom>
+          <a:noFill/>
+          <a:ln w="10800">
+            <a:noFill/>
+          </a:ln>
+        </p:spPr>
+        <p:style>
+          <a:lnRef idx="0"/>
+          <a:fillRef idx="0"/>
+          <a:effectRef idx="0"/>
+          <a:fontRef idx="minor"/>
+        </p:style>
+        <p:txBody>
+          <a:bodyPr lIns="90000" rIns="90000" tIns="45000" bIns="45000" anchor="ctr">
+            <a:spAutoFit/>
+          </a:bodyPr>
+          <a:p>
+            <a:pPr algn="ctr">
+              <a:lnSpc>
+                <a:spcPct val="100000"/>
+              </a:lnSpc>
+            </a:pPr>
+            <a:r>
+              <a:rPr b="1" lang="en-IN" sz="5400" strike="noStrike" u="none">
+                <a:solidFill>
+                  <a:srgbClr val="2c3e50"/>
+                </a:solidFill>
+                <a:effectLst/>
+                <a:uFillTx/>
+                <a:latin typeface="Noto Sans"/>
+              </a:rPr>
+              <a:t>Chart Customization</a:t>
+            </a:r>
+            <a:endParaRPr b="0" lang="en-IN" sz="5400" strike="noStrike" u="none">
+              <a:solidFill>
+                <a:srgbClr val="000000"/>
+              </a:solidFill>
+              <a:effectLst/>
+              <a:uFillTx/>
+              <a:latin typeface="Arial"/>
+            </a:endParaRPr>
+          </a:p>
+          <a:p>
+            <a:pPr algn="ctr">
+              <a:lnSpc>
+                <a:spcPct val="100000"/>
+              </a:lnSpc>
+            </a:pPr>
+            <a:r>
+              <a:rPr b="0" lang="en-IN" sz="2600" strike="noStrike" u="none">
+                <a:solidFill>
+                  <a:srgbClr val="2c3e50"/>
+                </a:solidFill>
+                <a:effectLst/>
+                <a:uFillTx/>
+                <a:latin typeface="Noto Sans"/>
+              </a:rPr>
+              <a:t>(Using Matplotlib)</a:t>
+            </a:r>
+            <a:endParaRPr b="0" lang="en-IN" sz="2600" strike="noStrike" u="none">
+              <a:solidFill>
+                <a:srgbClr val="000000"/>
+              </a:solidFill>
+              <a:effectLst/>
+              <a:uFillTx/>
+              <a:latin typeface="Arial"/>
+            </a:endParaRPr>
+          </a:p>
+        </p:txBody>
+      </p:sp>
+      <p:sp>
+        <p:nvSpPr>
+          <p:cNvPr id="3" name="PlaceHolder 2"/>
+          <p:cNvSpPr>
+            <a:spLocks noGrp="1"/>
+          </p:cNvSpPr>
+          <p:nvPr>
+            <p:ph type="sldNum" idx="3"/>
+          </p:nvPr>
+        </p:nvSpPr>
+        <p:spPr/>
+        <p:txBody>
+          <a:bodyPr/>
+          <a:p>
+            <a:fld id="{B1B00DFB-FFF7-493E-9803-70EB3BF19432}" type="slidenum">
+              <a:t>1</a:t>
+            </a:fld>
+          </a:p>
+        </p:txBody>
+      </p:sp>
+    </p:spTree>
+  </p:cSld>
+  <mc:AlternateContent>
+    <mc:Choice Requires="p14">
+      <p:transition spd="slow" p14:dur="2000"/>
+    </mc:Choice>
+    <mc:Fallback>
+      <p:transition spd="slow"/>
+    </mc:Fallback>
+  </mc:AlternateContent>
+</p:sld>
+</file>
+
+<file path=ppt/slides/slide2.xml><?xml version="1.0" encoding="utf-8"?>
+<p:sld xmlns:a="http://schemas.openxmlformats.org/drawingml/2006/main" xmlns:p="http://schemas.openxmlformats.org/presentationml/2006/main" xmlns:r="http://schemas.openxmlformats.org/officeDocument/2006/relationships" xmlns:p14="http://schemas.microsoft.com/office/powerpoint/2010/main" xmlns:p15="http://schemas.microsoft.com/office/powerpoint/2012/main" xmlns:mc="http://schemas.openxmlformats.org/markup-compatibility/2006">
+  <p:cSld>
+    <p:spTree>
+      <p:nvGrpSpPr>
+        <p:cNvPr id="1" name=""/>
+        <p:cNvGrpSpPr/>
+        <p:nvPr/>
+      </p:nvGrpSpPr>
+      <p:grpSpPr>
+        <a:xfrm>
+          <a:off x="0" y="0"/>
+          <a:ext cx="0" cy="0"/>
+          <a:chOff x="0" y="0"/>
+          <a:chExt cx="0" cy="0"/>
+        </a:xfrm>
+      </p:grpSpPr>
+      <p:sp>
+        <p:nvSpPr>
+          <p:cNvPr id="25" name="PlaceHolder 1"/>
+          <p:cNvSpPr>
+            <a:spLocks noGrp="1"/>
+          </p:cNvSpPr>
+          <p:nvPr>
+            <p:ph type="title"/>
+          </p:nvPr>
+        </p:nvSpPr>
+        <p:spPr>
+          <a:xfrm>
+            <a:off x="360000" y="225720"/>
+            <a:ext cx="9359640" cy="719640"/>
+          </a:xfrm>
+          <a:prstGeom prst="rect">
+            <a:avLst/>
+          </a:prstGeom>
+          <a:noFill/>
+          <a:ln w="0">
+            <a:noFill/>
+          </a:ln>
+        </p:spPr>
+        <p:txBody>
+          <a:bodyPr lIns="0" rIns="0" tIns="0" bIns="0" anchor="ctr">
+            <a:noAutofit/>
+          </a:bodyPr>
+          <a:p>
+            <a:pPr indent="0">
+              <a:lnSpc>
+                <a:spcPct val="100000"/>
+              </a:lnSpc>
+              <a:buNone/>
+              <a:tabLst>
+                <a:tab algn="l" pos="0"/>
+              </a:tabLst>
+            </a:pPr>
+            <a:r>
+              <a:rPr b="1" lang="en-IN" sz="6000" strike="noStrike" u="none">
+                <a:solidFill>
+                  <a:srgbClr val="ffffff"/>
+                </a:solidFill>
+                <a:effectLst/>
+                <a:uFillTx/>
+                <a:latin typeface="Noto Sans"/>
+              </a:rPr>
+              <a:t>GOAL</a:t>
+            </a:r>
+            <a:endParaRPr b="0" lang="en-IN" sz="6000" strike="noStrike" u="none">
+              <a:solidFill>
+                <a:srgbClr val="000000"/>
+              </a:solidFill>
+              <a:effectLst/>
+              <a:uFillTx/>
+              <a:latin typeface="Arial"/>
+            </a:endParaRPr>
+          </a:p>
+        </p:txBody>
+      </p:sp>
+      <p:sp>
+        <p:nvSpPr>
+          <p:cNvPr id="26" name="PlaceHolder 2"/>
+          <p:cNvSpPr>
+            <a:spLocks noGrp="1"/>
+          </p:cNvSpPr>
+          <p:nvPr>
+            <p:ph/>
+          </p:nvPr>
+        </p:nvSpPr>
+        <p:spPr>
+          <a:xfrm>
+            <a:off x="360000" y="1485000"/>
+            <a:ext cx="9359640" cy="3779640"/>
+          </a:xfrm>
+          <a:prstGeom prst="rect">
+            <a:avLst/>
+          </a:prstGeom>
+          <a:noFill/>
+          <a:ln w="0">
+            <a:noFill/>
+          </a:ln>
+        </p:spPr>
+        <p:txBody>
+          <a:bodyPr lIns="0" rIns="0" tIns="0" bIns="0" anchor="t">
+            <a:normAutofit/>
+          </a:bodyPr>
+          <a:p>
+            <a:pPr marL="432000" indent="-324000">
+              <a:lnSpc>
+                <a:spcPct val="100000"/>
+              </a:lnSpc>
+              <a:spcAft>
+                <a:spcPts val="1057"/>
+              </a:spcAft>
+              <a:buClr>
                 <a:srgbClr val="2c3e50"/>
-              </a:solidFill>
-              <a:effectLst/>
-              <a:uFillTx/>
-              <a:latin typeface="Noto Sans"/>
+              </a:buClr>
+              <a:buSzPct val="45000"/>
+              <a:buFont typeface="OpenSymbol"/>
+              <a:buChar char="►"/>
+            </a:pPr>
+            <a:r>
+              <a:rPr b="1" lang="en-IN" sz="2800" strike="noStrike" u="none">
+                <a:solidFill>
+                  <a:srgbClr val="2c3e50"/>
+                </a:solidFill>
+                <a:effectLst/>
+                <a:uFillTx/>
+                <a:latin typeface="Noto Sans"/>
+              </a:rPr>
+              <a:t>Communicate Data</a:t>
+            </a:r>
+            <a:endParaRPr b="0" lang="en-IN" sz="2800" strike="noStrike" u="none">
+              <a:solidFill>
+                <a:srgbClr val="000000"/>
+              </a:solidFill>
+              <a:effectLst/>
+              <a:uFillTx/>
+              <a:latin typeface="Arial"/>
+            </a:endParaRPr>
+          </a:p>
+          <a:p>
+            <a:pPr marL="432000" indent="-324000">
+              <a:lnSpc>
+                <a:spcPct val="100000"/>
+              </a:lnSpc>
+              <a:spcAft>
+                <a:spcPts val="1057"/>
+              </a:spcAft>
+              <a:buClr>
+                <a:srgbClr val="2c3e50"/>
+              </a:buClr>
+              <a:buSzPct val="45000"/>
+              <a:buFont typeface="OpenSymbol"/>
+              <a:buChar char="►"/>
+            </a:pPr>
+            <a:r>
+              <a:rPr b="1" lang="en-IN" sz="2800" strike="noStrike" u="none">
+                <a:solidFill>
+                  <a:srgbClr val="2c3e50"/>
+                </a:solidFill>
+                <a:effectLst/>
+                <a:uFillTx/>
+                <a:latin typeface="Noto Sans"/>
+              </a:rPr>
+              <a:t>Chart Customization</a:t>
+            </a:r>
+            <a:endParaRPr b="0" lang="en-IN" sz="2800" strike="noStrike" u="none">
+              <a:solidFill>
+                <a:srgbClr val="000000"/>
+              </a:solidFill>
+              <a:effectLst/>
+              <a:uFillTx/>
+              <a:latin typeface="Arial"/>
+            </a:endParaRPr>
+          </a:p>
+          <a:p>
+            <a:pPr marL="432000" indent="-324000">
+              <a:lnSpc>
+                <a:spcPct val="100000"/>
+              </a:lnSpc>
+              <a:spcAft>
+                <a:spcPts val="1057"/>
+              </a:spcAft>
+              <a:buClr>
+                <a:srgbClr val="2c3e50"/>
+              </a:buClr>
+              <a:buSzPct val="45000"/>
+              <a:buFont typeface="OpenSymbol"/>
+              <a:buChar char="►"/>
+            </a:pPr>
+            <a:r>
+              <a:rPr b="1" lang="en-IN" sz="2800" strike="noStrike" u="none">
+                <a:solidFill>
+                  <a:srgbClr val="2c3e50"/>
+                </a:solidFill>
+                <a:effectLst/>
+                <a:uFillTx/>
+                <a:latin typeface="Noto Sans"/>
+              </a:rPr>
+              <a:t>Compare Default Chart vs Customized Chart</a:t>
+            </a:r>
+            <a:endParaRPr b="0" lang="en-IN" sz="2800" strike="noStrike" u="none">
+              <a:solidFill>
+                <a:srgbClr val="000000"/>
+              </a:solidFill>
+              <a:effectLst/>
+              <a:uFillTx/>
+              <a:latin typeface="Arial"/>
+            </a:endParaRPr>
+          </a:p>
+          <a:p>
+            <a:pPr marL="432000" indent="0">
+              <a:lnSpc>
+                <a:spcPct val="100000"/>
+              </a:lnSpc>
+              <a:spcAft>
+                <a:spcPts val="1057"/>
+              </a:spcAft>
+              <a:buNone/>
+            </a:pPr>
+            <a:endParaRPr b="0" lang="en-IN" sz="2800" strike="noStrike" u="none">
+              <a:solidFill>
+                <a:srgbClr val="000000"/>
+              </a:solidFill>
+              <a:effectLst/>
+              <a:uFillTx/>
+              <a:latin typeface="Arial"/>
+            </a:endParaRPr>
+          </a:p>
+        </p:txBody>
+      </p:sp>
+      <p:sp>
+        <p:nvSpPr>
+          <p:cNvPr id="27" name=""/>
+          <p:cNvSpPr/>
+          <p:nvPr/>
+        </p:nvSpPr>
+        <p:spPr>
+          <a:xfrm>
+            <a:off x="360000" y="4860360"/>
+            <a:ext cx="3599640" cy="539640"/>
+          </a:xfrm>
+          <a:prstGeom prst="flowChartAlternateProcess">
+            <a:avLst/>
+          </a:prstGeom>
+          <a:solidFill>
+            <a:srgbClr val="ff0000"/>
+          </a:solidFill>
+          <a:ln w="10800">
+            <a:solidFill>
+              <a:srgbClr val="1abc9c"/>
+            </a:solidFill>
+            <a:round/>
+          </a:ln>
+        </p:spPr>
+        <p:style>
+          <a:lnRef idx="0"/>
+          <a:fillRef idx="0"/>
+          <a:effectRef idx="0"/>
+          <a:fontRef idx="minor"/>
+        </p:style>
+        <p:txBody>
+          <a:bodyPr wrap="none" lIns="90000" rIns="90000" tIns="45000" bIns="45000" anchor="ctr">
+            <a:noAutofit/>
+          </a:bodyPr>
+          <a:p>
+            <a:pPr algn="ctr">
+              <a:lnSpc>
+                <a:spcPct val="100000"/>
+              </a:lnSpc>
+            </a:pPr>
+            <a:r>
+              <a:rPr b="1" lang="en-IN" sz="1800" strike="noStrike" u="none">
+                <a:solidFill>
+                  <a:srgbClr val="ffffff"/>
+                </a:solidFill>
+                <a:effectLst/>
+                <a:uFillTx/>
+                <a:latin typeface="Noto Sans"/>
+                <a:ea typeface="DejaVu Sans"/>
+              </a:rPr>
+              <a:t>youtube.com/@ssutradhar35</a:t>
+            </a:r>
+            <a:endParaRPr b="0" lang="en-IN" sz="1800" strike="noStrike" u="none">
+              <a:solidFill>
+                <a:srgbClr val="ffffff"/>
+              </a:solidFill>
+              <a:effectLst/>
+              <a:uFillTx/>
+              <a:latin typeface="Arial"/>
             </a:endParaRPr>
           </a:p>
         </p:txBody>
@@ -2162,8 +2695,8 @@
         <p:txBody>
           <a:bodyPr/>
           <a:p>
-            <a:fld id="{764631DB-DE89-4FB5-8CD3-FFD10A92EF39}" type="slidenum">
-              <a:t>1</a:t>
+            <a:fld id="{55065194-443E-43AD-997D-D10EC4598057}" type="slidenum">
+              <a:t>2</a:t>
             </a:fld>
           </a:p>
         </p:txBody>
@@ -2212,7 +2745,7 @@
                                           </p:stCondLst>
                                         </p:cTn>
                                         <p:tgtEl>
-                                          <p:spTgt spid="23">
+                                          <p:spTgt spid="26">
                                             <p:txEl>
                                               <p:pRg st="0" end="0"/>
                                             </p:txEl>
@@ -2229,21 +2762,39 @@
                                   </p:childTnLst>
                                 </p:cTn>
                               </p:par>
+                            </p:childTnLst>
+                          </p:cTn>
+                        </p:par>
+                      </p:childTnLst>
+                    </p:cTn>
+                  </p:par>
+                  <p:par>
+                    <p:cTn id="7" fill="hold">
+                      <p:stCondLst>
+                        <p:cond delay="indefinite"/>
+                      </p:stCondLst>
+                      <p:childTnLst>
+                        <p:par>
+                          <p:cTn id="8" fill="hold">
+                            <p:stCondLst>
+                              <p:cond delay="0"/>
+                            </p:stCondLst>
+                            <p:childTnLst>
                               <p:par>
-                                <p:cTn id="7" nodeType="withEffect" fill="hold" presetClass="entr" presetID="1">
+                                <p:cTn id="9" nodeType="clickEffect" fill="hold" presetClass="entr" presetID="1">
                                   <p:stCondLst>
                                     <p:cond delay="0"/>
                                   </p:stCondLst>
                                   <p:childTnLst>
                                     <p:set>
                                       <p:cBhvr>
-                                        <p:cTn id="8" dur="1" fill="hold">
+                                        <p:cTn id="10" dur="1" fill="hold">
                                           <p:stCondLst>
                                             <p:cond delay="0"/>
                                           </p:stCondLst>
                                         </p:cTn>
                                         <p:tgtEl>
-                                          <p:spTgt spid="23">
+                                          <p:spTgt spid="26">
                                             <p:txEl>
                                               <p:pRg st="1" end="1"/>
                                             </p:txEl>
@@ -2260,21 +2811,39 @@
                                   </p:childTnLst>
                                 </p:cTn>
                               </p:par>
+                            </p:childTnLst>
+                          </p:cTn>
+                        </p:par>
+                      </p:childTnLst>
+                    </p:cTn>
+                  </p:par>
+                  <p:par>
+                    <p:cTn id="11" fill="hold">
+                      <p:stCondLst>
+                        <p:cond delay="indefinite"/>
+                      </p:stCondLst>
+                      <p:childTnLst>
+                        <p:par>
+                          <p:cTn id="12" fill="hold">
+                            <p:stCondLst>
+                              <p:cond delay="0"/>
+                            </p:stCondLst>
+                            <p:childTnLst>
                               <p:par>
-                                <p:cTn id="9" nodeType="withEffect" fill="hold" presetClass="entr" presetID="1">
+                                <p:cTn id="13" nodeType="clickEffect" fill="hold" presetClass="entr" presetID="1">
                                   <p:stCondLst>
                                     <p:cond delay="0"/>
                                   </p:stCondLst>
                                   <p:childTnLst>
                                     <p:set>
                                       <p:cBhvr>
-                                        <p:cTn id="10" dur="1" fill="hold">
+                                        <p:cTn id="14" dur="1" fill="hold">
                                           <p:stCondLst>
                                             <p:cond delay="0"/>
                                           </p:stCondLst>
                                         </p:cTn>
                                         <p:tgtEl>
-                                          <p:spTgt spid="23">
+                                          <p:spTgt spid="26">
                                             <p:txEl>
                                               <p:pRg st="2" end="2"/>
                                             </p:txEl>
@@ -2291,21 +2860,39 @@
                                   </p:childTnLst>
                                 </p:cTn>
                               </p:par>
+                            </p:childTnLst>
+                          </p:cTn>
+                        </p:par>
+                      </p:childTnLst>
+                    </p:cTn>
+                  </p:par>
+                  <p:par>
+                    <p:cTn id="15" fill="hold">
+                      <p:stCondLst>
+                        <p:cond delay="indefinite"/>
+                      </p:stCondLst>
+                      <p:childTnLst>
+                        <p:par>
+                          <p:cTn id="16" fill="hold">
+                            <p:stCondLst>
+                              <p:cond delay="0"/>
+                            </p:stCondLst>
+                            <p:childTnLst>
                               <p:par>
-                                <p:cTn id="11" nodeType="withEffect" fill="hold" presetClass="entr" presetID="1">
+                                <p:cTn id="17" nodeType="clickEffect" fill="hold" presetClass="entr" presetID="1">
                                   <p:stCondLst>
                                     <p:cond delay="0"/>
                                   </p:stCondLst>
                                   <p:childTnLst>
                                     <p:set>
                                       <p:cBhvr>
-                                        <p:cTn id="12" dur="1" fill="hold">
+                                        <p:cTn id="18" dur="1" fill="hold">
                                           <p:stCondLst>
                                             <p:cond delay="0"/>
                                           </p:stCondLst>
                                         </p:cTn>
                                         <p:tgtEl>
-                                          <p:spTgt spid="23">
+                                          <p:spTgt spid="26">
                                             <p:txEl>
                                               <p:pRg st="3" end="3"/>
                                             </p:txEl>
@@ -2353,240 +2940,6 @@
 </p:sld>
 </file>
 
-<file path=ppt/slides/slide2.xml><?xml version="1.0" encoding="utf-8"?>
-<p:sld xmlns:a="http://schemas.openxmlformats.org/drawingml/2006/main" xmlns:p="http://schemas.openxmlformats.org/presentationml/2006/main" xmlns:r="http://schemas.openxmlformats.org/officeDocument/2006/relationships" xmlns:p14="http://schemas.microsoft.com/office/powerpoint/2010/main" xmlns:p15="http://schemas.microsoft.com/office/powerpoint/2012/main" xmlns:mc="http://schemas.openxmlformats.org/markup-compatibility/2006">
-  <p:cSld>
-    <p:spTree>
-      <p:nvGrpSpPr>
-        <p:cNvPr id="1" name=""/>
-        <p:cNvGrpSpPr/>
-        <p:nvPr/>
-      </p:nvGrpSpPr>
-      <p:grpSpPr>
-        <a:xfrm>
-          <a:off x="0" y="0"/>
-          <a:ext cx="0" cy="0"/>
-          <a:chOff x="0" y="0"/>
-          <a:chExt cx="0" cy="0"/>
-        </a:xfrm>
-      </p:grpSpPr>
-      <p:sp>
-        <p:nvSpPr>
-          <p:cNvPr id="25" name="PlaceHolder 1"/>
-          <p:cNvSpPr>
-            <a:spLocks noGrp="1"/>
-          </p:cNvSpPr>
-          <p:nvPr>
-            <p:ph type="title"/>
-          </p:nvPr>
-        </p:nvSpPr>
-        <p:spPr>
-          <a:xfrm>
-            <a:off x="360000" y="225720"/>
-            <a:ext cx="9360000" cy="720000"/>
-          </a:xfrm>
-          <a:prstGeom prst="rect">
-            <a:avLst/>
-          </a:prstGeom>
-          <a:noFill/>
-          <a:ln w="0">
-            <a:noFill/>
-          </a:ln>
-        </p:spPr>
-        <p:txBody>
-          <a:bodyPr lIns="0" rIns="0" tIns="0" bIns="0" anchor="ctr">
-            <a:noAutofit/>
-          </a:bodyPr>
-          <a:p>
-            <a:pPr indent="0">
-              <a:buNone/>
-            </a:pPr>
-            <a:r>
-              <a:rPr b="1" lang="en-IN" sz="6000" strike="noStrike" u="none">
-                <a:solidFill>
-                  <a:srgbClr val="ffffff"/>
-                </a:solidFill>
-                <a:effectLst/>
-                <a:uFillTx/>
-                <a:latin typeface="Noto Sans"/>
-              </a:rPr>
-              <a:t>PROJECT</a:t>
-            </a:r>
-            <a:endParaRPr b="1" lang="en-IN" sz="6000" strike="noStrike" u="none">
-              <a:solidFill>
-                <a:srgbClr val="ffffff"/>
-              </a:solidFill>
-              <a:effectLst/>
-              <a:uFillTx/>
-              <a:latin typeface="Noto Sans"/>
-            </a:endParaRPr>
-          </a:p>
-        </p:txBody>
-      </p:sp>
-      <p:sp>
-        <p:nvSpPr>
-          <p:cNvPr id="26" name=""/>
-          <p:cNvSpPr/>
-          <p:nvPr/>
-        </p:nvSpPr>
-        <p:spPr>
-          <a:xfrm>
-            <a:off x="360000" y="4860000"/>
-            <a:ext cx="3600000" cy="540000"/>
-          </a:xfrm>
-          <a:prstGeom prst="flowChartAlternateProcess">
-            <a:avLst/>
-          </a:prstGeom>
-          <a:solidFill>
-            <a:srgbClr val="ff0000"/>
-          </a:solidFill>
-          <a:ln w="10800">
-            <a:solidFill>
-              <a:srgbClr val="1abc9c"/>
-            </a:solidFill>
-            <a:round/>
-          </a:ln>
-        </p:spPr>
-        <p:style>
-          <a:lnRef idx="0"/>
-          <a:fillRef idx="0"/>
-          <a:effectRef idx="0"/>
-          <a:fontRef idx="minor"/>
-        </p:style>
-        <p:txBody>
-          <a:bodyPr wrap="none" lIns="90000" rIns="90000" tIns="45000" bIns="45000" anchor="ctr">
-            <a:noAutofit/>
-          </a:bodyPr>
-          <a:p>
-            <a:pPr algn="ctr">
-              <a:lnSpc>
-                <a:spcPct val="100000"/>
-              </a:lnSpc>
-            </a:pPr>
-            <a:r>
-              <a:rPr b="1" lang="en-IN" sz="1800" strike="noStrike" u="none">
-                <a:solidFill>
-                  <a:srgbClr val="ffffff"/>
-                </a:solidFill>
-                <a:effectLst/>
-                <a:uFillTx/>
-                <a:latin typeface="Noto Sans"/>
-              </a:rPr>
-              <a:t>youtube.com/@ssutradhar35</a:t>
-            </a:r>
-            <a:endParaRPr b="0" lang="en-IN" sz="1800" strike="noStrike" u="none">
-              <a:solidFill>
-                <a:srgbClr val="2c3e50"/>
-              </a:solidFill>
-              <a:effectLst/>
-              <a:uFillTx/>
-              <a:latin typeface="Noto Sans"/>
-            </a:endParaRPr>
-          </a:p>
-        </p:txBody>
-      </p:sp>
-      <p:sp>
-        <p:nvSpPr>
-          <p:cNvPr id="27" name=""/>
-          <p:cNvSpPr txBox="1"/>
-          <p:nvPr/>
-        </p:nvSpPr>
-        <p:spPr>
-          <a:xfrm>
-            <a:off x="720000" y="1800000"/>
-            <a:ext cx="8640000" cy="2160000"/>
-          </a:xfrm>
-          <a:prstGeom prst="rect">
-            <a:avLst/>
-          </a:prstGeom>
-          <a:noFill/>
-          <a:ln w="10800">
-            <a:noFill/>
-          </a:ln>
-        </p:spPr>
-        <p:txBody>
-          <a:bodyPr lIns="90000" rIns="90000" tIns="45000" bIns="45000" anchor="ctr">
-            <a:spAutoFit/>
-          </a:bodyPr>
-          <a:p>
-            <a:pPr algn="ctr"/>
-            <a:r>
-              <a:rPr b="1" lang="en-IN" sz="5400" strike="noStrike" u="none">
-                <a:solidFill>
-                  <a:srgbClr val="2c3e50"/>
-                </a:solidFill>
-                <a:effectLst/>
-                <a:uFillTx/>
-                <a:latin typeface="Noto Sans"/>
-              </a:rPr>
-              <a:t>Student Marks Analysis</a:t>
-            </a:r>
-            <a:endParaRPr b="0" lang="en-IN" sz="5400" strike="noStrike" u="none">
-              <a:solidFill>
-                <a:srgbClr val="2c3e50"/>
-              </a:solidFill>
-              <a:effectLst/>
-              <a:uFillTx/>
-              <a:latin typeface="Noto Sans"/>
-            </a:endParaRPr>
-          </a:p>
-          <a:p>
-            <a:pPr algn="ctr"/>
-            <a:r>
-              <a:rPr b="0" lang="en-IN" sz="2600" strike="noStrike" u="none">
-                <a:solidFill>
-                  <a:srgbClr val="2c3e50"/>
-                </a:solidFill>
-                <a:effectLst/>
-                <a:uFillTx/>
-                <a:latin typeface="Noto Sans"/>
-              </a:rPr>
-              <a:t>(Using Pandas and Matplotlib)</a:t>
-            </a:r>
-            <a:endParaRPr b="0" lang="en-IN" sz="2600" strike="noStrike" u="none">
-              <a:solidFill>
-                <a:srgbClr val="2c3e50"/>
-              </a:solidFill>
-              <a:effectLst/>
-              <a:uFillTx/>
-              <a:latin typeface="Noto Sans"/>
-            </a:endParaRPr>
-          </a:p>
-        </p:txBody>
-      </p:sp>
-      <p:sp>
-        <p:nvSpPr>
-          <p:cNvPr id="3" name="PlaceHolder 2"/>
-          <p:cNvSpPr>
-            <a:spLocks noGrp="1"/>
-          </p:cNvSpPr>
-          <p:nvPr>
-            <p:ph type="sldNum" idx="3"/>
-          </p:nvPr>
-        </p:nvSpPr>
-        <p:spPr/>
-        <p:txBody>
-          <a:bodyPr/>
-          <a:p>
-            <a:fld id="{6C6553CE-025B-4294-89F9-10FBDF7C22ED}" type="slidenum">
-              <a:t>2</a:t>
-            </a:fld>
-          </a:p>
-        </p:txBody>
-      </p:sp>
-    </p:spTree>
-  </p:cSld>
-  <mc:AlternateContent>
-    <mc:Choice Requires="p14">
-      <p:transition spd="slow" p14:dur="2000"/>
-    </mc:Choice>
-    <mc:Fallback>
-      <p:transition spd="slow"/>
-    </mc:Fallback>
-  </mc:AlternateContent>
-</p:sld>
-</file>
-
 <file path=ppt/slides/slide3.xml><?xml version="1.0" encoding="utf-8"?>
 <p:sld xmlns:a="http://schemas.openxmlformats.org/drawingml/2006/main" xmlns:p="http://schemas.openxmlformats.org/presentationml/2006/main" xmlns:r="http://schemas.openxmlformats.org/officeDocument/2006/relationships" xmlns:p14="http://schemas.microsoft.com/office/powerpoint/2010/main" xmlns:p15="http://schemas.microsoft.com/office/powerpoint/2012/main" xmlns:mc="http://schemas.openxmlformats.org/markup-compatibility/2006">
   <p:cSld>
@@ -2617,7 +2970,7 @@
         <p:spPr>
           <a:xfrm>
             <a:off x="360000" y="225720"/>
-            <a:ext cx="9360000" cy="720000"/>
+            <a:ext cx="9359640" cy="719640"/>
           </a:xfrm>
           <a:prstGeom prst="rect">
             <a:avLst/>
@@ -2633,7 +2986,13 @@
           </a:bodyPr>
           <a:p>
             <a:pPr indent="0">
-              <a:buNone/>
+              <a:lnSpc>
+                <a:spcPct val="100000"/>
+              </a:lnSpc>
+              <a:buNone/>
+              <a:tabLst>
+                <a:tab algn="l" pos="0"/>
+              </a:tabLst>
             </a:pPr>
             <a:r>
               <a:rPr b="1" lang="en-IN" sz="6000" strike="noStrike" u="none">
@@ -2644,15 +3003,15 @@
                 <a:uFillTx/>
                 <a:latin typeface="Noto Sans"/>
               </a:rPr>
-              <a:t>GOAL</a:t>
-            </a:r>
-            <a:endParaRPr b="1" lang="en-IN" sz="6000" strike="noStrike" u="none">
-              <a:solidFill>
-                <a:srgbClr val="ffffff"/>
-              </a:solidFill>
-              <a:effectLst/>
-              <a:uFillTx/>
-              <a:latin typeface="Noto Sans"/>
+              <a:t>SUMMARY</a:t>
+            </a:r>
+            <a:endParaRPr b="0" lang="en-IN" sz="6000" strike="noStrike" u="none">
+              <a:solidFill>
+                <a:srgbClr val="000000"/>
+              </a:solidFill>
+              <a:effectLst/>
+              <a:uFillTx/>
+              <a:latin typeface="Arial"/>
             </a:endParaRPr>
           </a:p>
         </p:txBody>
@@ -2670,7 +3029,7 @@
         <p:spPr>
           <a:xfrm>
             <a:off x="360000" y="1485000"/>
-            <a:ext cx="9360000" cy="3780000"/>
+            <a:ext cx="9359640" cy="3779640"/>
           </a:xfrm>
           <a:prstGeom prst="rect">
             <a:avLst/>
@@ -2686,6 +3045,9 @@
           </a:bodyPr>
           <a:p>
             <a:pPr marL="432000" indent="-324000">
+              <a:lnSpc>
+                <a:spcPct val="100000"/>
+              </a:lnSpc>
               <a:spcAft>
                 <a:spcPts val="1057"/>
               </a:spcAft>
@@ -2705,19 +3067,22 @@
                 <a:uFillTx/>
                 <a:latin typeface="Noto Sans"/>
               </a:rPr>
-              <a:t>Analyze student performance</a:t>
-            </a:r>
-            <a:endParaRPr b="1" lang="en-IN" sz="2800" strike="noStrike" u="none">
-              <a:solidFill>
-                <a:srgbClr val="2c3e50"/>
-              </a:solidFill>
-              <a:effectLst/>
-              <a:uFillTx/>
-              <a:latin typeface="Noto Sans"/>
+              <a:t>suptitle(), subplots(rows, cols, position)</a:t>
+            </a:r>
+            <a:endParaRPr b="0" lang="en-IN" sz="2800" strike="noStrike" u="none">
+              <a:solidFill>
+                <a:srgbClr val="000000"/>
+              </a:solidFill>
+              <a:effectLst/>
+              <a:uFillTx/>
+              <a:latin typeface="Arial"/>
             </a:endParaRPr>
           </a:p>
           <a:p>
             <a:pPr marL="432000" indent="-324000">
+              <a:lnSpc>
+                <a:spcPct val="100000"/>
+              </a:lnSpc>
               <a:spcAft>
                 <a:spcPts val="1057"/>
               </a:spcAft>
@@ -2737,19 +3102,22 @@
                 <a:uFillTx/>
                 <a:latin typeface="Noto Sans"/>
               </a:rPr>
-              <a:t>Create charts</a:t>
-            </a:r>
-            <a:endParaRPr b="1" lang="en-IN" sz="2800" strike="noStrike" u="none">
-              <a:solidFill>
-                <a:srgbClr val="2c3e50"/>
-              </a:solidFill>
-              <a:effectLst/>
-              <a:uFillTx/>
-              <a:latin typeface="Noto Sans"/>
+              <a:t>color, marker, linestyle, linewidth</a:t>
+            </a:r>
+            <a:endParaRPr b="0" lang="en-IN" sz="2800" strike="noStrike" u="none">
+              <a:solidFill>
+                <a:srgbClr val="000000"/>
+              </a:solidFill>
+              <a:effectLst/>
+              <a:uFillTx/>
+              <a:latin typeface="Arial"/>
             </a:endParaRPr>
           </a:p>
           <a:p>
             <a:pPr marL="432000" indent="-324000">
+              <a:lnSpc>
+                <a:spcPct val="100000"/>
+              </a:lnSpc>
               <a:spcAft>
                 <a:spcPts val="1057"/>
               </a:spcAft>
@@ -2769,19 +3137,22 @@
                 <a:uFillTx/>
                 <a:latin typeface="Noto Sans"/>
               </a:rPr>
-              <a:t>Generate insights</a:t>
-            </a:r>
-            <a:endParaRPr b="1" lang="en-IN" sz="2800" strike="noStrike" u="none">
-              <a:solidFill>
-                <a:srgbClr val="2c3e50"/>
-              </a:solidFill>
-              <a:effectLst/>
-              <a:uFillTx/>
-              <a:latin typeface="Noto Sans"/>
+              <a:t>label, legend() </a:t>
+            </a:r>
+            <a:endParaRPr b="0" lang="en-IN" sz="2800" strike="noStrike" u="none">
+              <a:solidFill>
+                <a:srgbClr val="000000"/>
+              </a:solidFill>
+              <a:effectLst/>
+              <a:uFillTx/>
+              <a:latin typeface="Arial"/>
             </a:endParaRPr>
           </a:p>
           <a:p>
             <a:pPr marL="432000" indent="-324000">
+              <a:lnSpc>
+                <a:spcPct val="100000"/>
+              </a:lnSpc>
               <a:spcAft>
                 <a:spcPts val="1057"/>
               </a:spcAft>
@@ -2801,15 +3172,50 @@
                 <a:uFillTx/>
                 <a:latin typeface="Noto Sans"/>
               </a:rPr>
-              <a:t>Provide recommendations to school management</a:t>
-            </a:r>
-            <a:endParaRPr b="1" lang="en-IN" sz="2800" strike="noStrike" u="none">
-              <a:solidFill>
+              <a:t>figure(figsize, dpi)</a:t>
+            </a:r>
+            <a:endParaRPr b="0" lang="en-IN" sz="2800" strike="noStrike" u="none">
+              <a:solidFill>
+                <a:srgbClr val="000000"/>
+              </a:solidFill>
+              <a:effectLst/>
+              <a:uFillTx/>
+              <a:latin typeface="Arial"/>
+            </a:endParaRPr>
+          </a:p>
+          <a:p>
+            <a:pPr marL="432000" indent="-324000">
+              <a:lnSpc>
+                <a:spcPct val="100000"/>
+              </a:lnSpc>
+              <a:spcAft>
+                <a:spcPts val="1057"/>
+              </a:spcAft>
+              <a:buClr>
                 <a:srgbClr val="2c3e50"/>
-              </a:solidFill>
-              <a:effectLst/>
-              <a:uFillTx/>
-              <a:latin typeface="Noto Sans"/>
+              </a:buClr>
+              <a:buSzPct val="45000"/>
+              <a:buFont typeface="OpenSymbol"/>
+              <a:buChar char="►"/>
+            </a:pPr>
+            <a:r>
+              <a:rPr b="1" lang="en-IN" sz="2800" strike="noStrike" u="none">
+                <a:solidFill>
+                  <a:srgbClr val="2c3e50"/>
+                </a:solidFill>
+                <a:effectLst/>
+                <a:uFillTx/>
+                <a:latin typeface="Noto Sans"/>
+              </a:rPr>
+              <a:t>xticks(rotation)</a:t>
+            </a:r>
+            <a:endParaRPr b="0" lang="en-IN" sz="2800" strike="noStrike" u="none">
+              <a:solidFill>
+                <a:srgbClr val="000000"/>
+              </a:solidFill>
+              <a:effectLst/>
+              <a:uFillTx/>
+              <a:latin typeface="Arial"/>
             </a:endParaRPr>
           </a:p>
         </p:txBody>
@@ -2823,7 +3229,7 @@
         <p:spPr>
           <a:xfrm>
             <a:off x="360000" y="4860360"/>
-            <a:ext cx="3600000" cy="540000"/>
+            <a:ext cx="3599640" cy="539640"/>
           </a:xfrm>
           <a:prstGeom prst="flowChartAlternateProcess">
             <a:avLst/>
@@ -2862,16 +3268,17 @@
                 <a:effectLst/>
                 <a:uFillTx/>
                 <a:latin typeface="Noto Sans"/>
+                <a:ea typeface="DejaVu Sans"/>
               </a:rPr>
               <a:t>youtube.com/@ssutradhar35</a:t>
             </a:r>
             <a:endParaRPr b="0" lang="en-IN" sz="1800" strike="noStrike" u="none">
               <a:solidFill>
-                <a:srgbClr val="2c3e50"/>
-              </a:solidFill>
-              <a:effectLst/>
-              <a:uFillTx/>
-              <a:latin typeface="Noto Sans"/>
+                <a:srgbClr val="ffffff"/>
+              </a:solidFill>
+              <a:effectLst/>
+              <a:uFillTx/>
+              <a:latin typeface="Arial"/>
             </a:endParaRPr>
           </a:p>
         </p:txBody>
@@ -2890,588 +3297,8 @@
         <p:txBody>
           <a:bodyPr/>
           <a:p>
-            <a:fld id="{28629680-14AA-4CD4-819E-0D334DB70353}" type="slidenum">
+            <a:fld id="{6E988FD2-F348-4188-82F3-5321212E9A09}" type="slidenum">
               <a:t>3</a:t>
-            </a:fld>
-          </a:p>
-        </p:txBody>
-      </p:sp>
-    </p:spTree>
-  </p:cSld>
-  <mc:AlternateContent>
-    <mc:Choice Requires="p14">
-      <p:transition spd="slow" p14:dur="2000"/>
-    </mc:Choice>
-    <mc:Fallback>
-      <p:transition spd="slow"/>
-    </mc:Fallback>
-  </mc:AlternateContent>
-  <p:timing>
-    <p:tnLst>
-      <p:par>
-        <p:cTn id="13" dur="indefinite" restart="never" nodeType="tmRoot">
-          <p:childTnLst>
-            <p:seq>
-              <p:cTn id="14" dur="indefinite" nodeType="mainSeq">
-                <p:childTnLst>
-                  <p:par>
-                    <p:cTn id="15" fill="hold">
-                      <p:stCondLst>
-                        <p:cond delay="indefinite"/>
-                      </p:stCondLst>
-                      <p:childTnLst>
-                        <p:par>
-                          <p:cTn id="16" fill="hold">
-                            <p:stCondLst>
-                              <p:cond delay="0"/>
-                            </p:stCondLst>
-                            <p:childTnLst>
-                              <p:par>
-                                <p:cTn id="17" nodeType="clickEffect" fill="hold" presetClass="entr" presetID="1">
-                                  <p:stCondLst>
-                                    <p:cond delay="0"/>
-                                  </p:stCondLst>
-                                  <p:childTnLst>
-                                    <p:set>
-                                      <p:cBhvr>
-                                        <p:cTn id="18" dur="1" fill="hold">
-                                          <p:stCondLst>
-                                            <p:cond delay="0"/>
-                                          </p:stCondLst>
-                                        </p:cTn>
-                                        <p:tgtEl>
-                                          <p:spTgt spid="29">
-                                            <p:txEl>
-                                              <p:pRg st="0" end="0"/>
-                                            </p:txEl>
-                                          </p:spTgt>
-                                        </p:tgtEl>
-                                        <p:attrNameLst>
-                                          <p:attrName>style.visibility</p:attrName>
-                                        </p:attrNameLst>
-                                      </p:cBhvr>
-                                      <p:to>
-                                        <p:strVal val="visible"/>
-                                      </p:to>
-                                    </p:set>
-                                  </p:childTnLst>
-                                </p:cTn>
-                              </p:par>
-                            </p:childTnLst>
-                          </p:cTn>
-                        </p:par>
-                      </p:childTnLst>
-                    </p:cTn>
-                  </p:par>
-                  <p:par>
-                    <p:cTn id="19" fill="hold">
-                      <p:stCondLst>
-                        <p:cond delay="indefinite"/>
-                      </p:stCondLst>
-                      <p:childTnLst>
-                        <p:par>
-                          <p:cTn id="20" fill="hold">
-                            <p:stCondLst>
-                              <p:cond delay="0"/>
-                            </p:stCondLst>
-                            <p:childTnLst>
-                              <p:par>
-                                <p:cTn id="21" nodeType="clickEffect" fill="hold" presetClass="entr" presetID="1">
-                                  <p:stCondLst>
-                                    <p:cond delay="0"/>
-                                  </p:stCondLst>
-                                  <p:childTnLst>
-                                    <p:set>
-                                      <p:cBhvr>
-                                        <p:cTn id="22" dur="1" fill="hold">
-                                          <p:stCondLst>
-                                            <p:cond delay="0"/>
-                                          </p:stCondLst>
-                                        </p:cTn>
-                                        <p:tgtEl>
-                                          <p:spTgt spid="29">
-                                            <p:txEl>
-                                              <p:pRg st="1" end="1"/>
-                                            </p:txEl>
-                                          </p:spTgt>
-                                        </p:tgtEl>
-                                        <p:attrNameLst>
-                                          <p:attrName>style.visibility</p:attrName>
-                                        </p:attrNameLst>
-                                      </p:cBhvr>
-                                      <p:to>
-                                        <p:strVal val="visible"/>
-                                      </p:to>
-                                    </p:set>
-                                  </p:childTnLst>
-                                </p:cTn>
-                              </p:par>
-                            </p:childTnLst>
-                          </p:cTn>
-                        </p:par>
-                      </p:childTnLst>
-                    </p:cTn>
-                  </p:par>
-                  <p:par>
-                    <p:cTn id="23" fill="hold">
-                      <p:stCondLst>
-                        <p:cond delay="indefinite"/>
-                      </p:stCondLst>
-                      <p:childTnLst>
-                        <p:par>
-                          <p:cTn id="24" fill="hold">
-                            <p:stCondLst>
-                              <p:cond delay="0"/>
-                            </p:stCondLst>
-                            <p:childTnLst>
-                              <p:par>
-                                <p:cTn id="25" nodeType="clickEffect" fill="hold" presetClass="entr" presetID="1">
-                                  <p:stCondLst>
-                                    <p:cond delay="0"/>
-                                  </p:stCondLst>
-                                  <p:childTnLst>
-                                    <p:set>
-                                      <p:cBhvr>
-                                        <p:cTn id="26" dur="1" fill="hold">
-                                          <p:stCondLst>
-                                            <p:cond delay="0"/>
-                                          </p:stCondLst>
-                                        </p:cTn>
-                                        <p:tgtEl>
-                                          <p:spTgt spid="29">
-                                            <p:txEl>
-                                              <p:pRg st="2" end="2"/>
-                                            </p:txEl>
-                                          </p:spTgt>
-                                        </p:tgtEl>
-                                        <p:attrNameLst>
-                                          <p:attrName>style.visibility</p:attrName>
-                                        </p:attrNameLst>
-                                      </p:cBhvr>
-                                      <p:to>
-                                        <p:strVal val="visible"/>
-                                      </p:to>
-                                    </p:set>
-                                  </p:childTnLst>
-                                </p:cTn>
-                              </p:par>
-                            </p:childTnLst>
-                          </p:cTn>
-                        </p:par>
-                      </p:childTnLst>
-                    </p:cTn>
-                  </p:par>
-                  <p:par>
-                    <p:cTn id="27" fill="hold">
-                      <p:stCondLst>
-                        <p:cond delay="indefinite"/>
-                      </p:stCondLst>
-                      <p:childTnLst>
-                        <p:par>
-                          <p:cTn id="28" fill="hold">
-                            <p:stCondLst>
-                              <p:cond delay="0"/>
-                            </p:stCondLst>
-                            <p:childTnLst>
-                              <p:par>
-                                <p:cTn id="29" nodeType="clickEffect" fill="hold" presetClass="entr" presetID="1">
-                                  <p:stCondLst>
-                                    <p:cond delay="0"/>
-                                  </p:stCondLst>
-                                  <p:childTnLst>
-                                    <p:set>
-                                      <p:cBhvr>
-                                        <p:cTn id="30" dur="1" fill="hold">
-                                          <p:stCondLst>
-                                            <p:cond delay="0"/>
-                                          </p:stCondLst>
-                                        </p:cTn>
-                                        <p:tgtEl>
-                                          <p:spTgt spid="29">
-                                            <p:txEl>
-                                              <p:pRg st="3" end="3"/>
-                                            </p:txEl>
-                                          </p:spTgt>
-                                        </p:tgtEl>
-                                        <p:attrNameLst>
-                                          <p:attrName>style.visibility</p:attrName>
-                                        </p:attrNameLst>
-                                      </p:cBhvr>
-                                      <p:to>
-                                        <p:strVal val="visible"/>
-                                      </p:to>
-                                    </p:set>
-                                  </p:childTnLst>
-                                </p:cTn>
-                              </p:par>
-                            </p:childTnLst>
-                          </p:cTn>
-                        </p:par>
-                      </p:childTnLst>
-                    </p:cTn>
-                  </p:par>
-                </p:childTnLst>
-              </p:cTn>
-              <p:prevCondLst>
-                <p:cond evt="onPrev">
-                  <p:tgtEl>
-                    <p:sldTgt/>
-                  </p:tgtEl>
-                </p:cond>
-              </p:prevCondLst>
-              <p:nextCondLst>
-                <p:cond evt="onNext">
-                  <p:tgtEl>
-                    <p:sldTgt/>
-                  </p:tgtEl>
-                </p:cond>
-              </p:nextCondLst>
-            </p:seq>
-          </p:childTnLst>
-        </p:cTn>
-      </p:par>
-    </p:tnLst>
-  </p:timing>
-</p:sld>
-</file>
-
-<file path=ppt/slides/slide4.xml><?xml version="1.0" encoding="utf-8"?>
-<p:sld xmlns:a="http://schemas.openxmlformats.org/drawingml/2006/main" xmlns:p="http://schemas.openxmlformats.org/presentationml/2006/main" xmlns:r="http://schemas.openxmlformats.org/officeDocument/2006/relationships" xmlns:p14="http://schemas.microsoft.com/office/powerpoint/2010/main" xmlns:p15="http://schemas.microsoft.com/office/powerpoint/2012/main" xmlns:mc="http://schemas.openxmlformats.org/markup-compatibility/2006">
-  <p:cSld>
-    <p:spTree>
-      <p:nvGrpSpPr>
-        <p:cNvPr id="1" name=""/>
-        <p:cNvGrpSpPr/>
-        <p:nvPr/>
-      </p:nvGrpSpPr>
-      <p:grpSpPr>
-        <a:xfrm>
-          <a:off x="0" y="0"/>
-          <a:ext cx="0" cy="0"/>
-          <a:chOff x="0" y="0"/>
-          <a:chExt cx="0" cy="0"/>
-        </a:xfrm>
-      </p:grpSpPr>
-      <p:sp>
-        <p:nvSpPr>
-          <p:cNvPr id="31" name="PlaceHolder 1"/>
-          <p:cNvSpPr>
-            <a:spLocks noGrp="1"/>
-          </p:cNvSpPr>
-          <p:nvPr>
-            <p:ph type="title"/>
-          </p:nvPr>
-        </p:nvSpPr>
-        <p:spPr>
-          <a:xfrm>
-            <a:off x="360000" y="225720"/>
-            <a:ext cx="9360000" cy="720000"/>
-          </a:xfrm>
-          <a:prstGeom prst="rect">
-            <a:avLst/>
-          </a:prstGeom>
-          <a:noFill/>
-          <a:ln w="0">
-            <a:noFill/>
-          </a:ln>
-        </p:spPr>
-        <p:txBody>
-          <a:bodyPr lIns="0" rIns="0" tIns="0" bIns="0" anchor="ctr">
-            <a:noAutofit/>
-          </a:bodyPr>
-          <a:p>
-            <a:pPr indent="0">
-              <a:buNone/>
-            </a:pPr>
-            <a:r>
-              <a:rPr b="1" lang="en-IN" sz="6000" strike="noStrike" u="none">
-                <a:solidFill>
-                  <a:srgbClr val="ffffff"/>
-                </a:solidFill>
-                <a:effectLst/>
-                <a:uFillTx/>
-                <a:latin typeface="Noto Sans"/>
-              </a:rPr>
-              <a:t>SUMMARY</a:t>
-            </a:r>
-            <a:endParaRPr b="1" lang="en-IN" sz="6000" strike="noStrike" u="none">
-              <a:solidFill>
-                <a:srgbClr val="ffffff"/>
-              </a:solidFill>
-              <a:effectLst/>
-              <a:uFillTx/>
-              <a:latin typeface="Noto Sans"/>
-            </a:endParaRPr>
-          </a:p>
-        </p:txBody>
-      </p:sp>
-      <p:sp>
-        <p:nvSpPr>
-          <p:cNvPr id="32" name="PlaceHolder 2"/>
-          <p:cNvSpPr>
-            <a:spLocks noGrp="1"/>
-          </p:cNvSpPr>
-          <p:nvPr>
-            <p:ph/>
-          </p:nvPr>
-        </p:nvSpPr>
-        <p:spPr>
-          <a:xfrm>
-            <a:off x="360000" y="1485000"/>
-            <a:ext cx="9360000" cy="3780000"/>
-          </a:xfrm>
-          <a:prstGeom prst="rect">
-            <a:avLst/>
-          </a:prstGeom>
-          <a:noFill/>
-          <a:ln w="0">
-            <a:noFill/>
-          </a:ln>
-        </p:spPr>
-        <p:txBody>
-          <a:bodyPr lIns="0" rIns="0" tIns="0" bIns="0" anchor="t">
-            <a:normAutofit/>
-          </a:bodyPr>
-          <a:p>
-            <a:pPr marL="432000" indent="-324000">
-              <a:spcAft>
-                <a:spcPts val="1057"/>
-              </a:spcAft>
-              <a:buClr>
-                <a:srgbClr val="2c3e50"/>
-              </a:buClr>
-              <a:buSzPct val="45000"/>
-              <a:buFont typeface="OpenSymbol"/>
-              <a:buChar char="►"/>
-            </a:pPr>
-            <a:r>
-              <a:rPr b="1" lang="en-IN" sz="2800" strike="noStrike" u="none">
-                <a:solidFill>
-                  <a:srgbClr val="2c3e50"/>
-                </a:solidFill>
-                <a:effectLst/>
-                <a:uFillTx/>
-                <a:latin typeface="Noto Sans"/>
-              </a:rPr>
-              <a:t>read_csv()</a:t>
-            </a:r>
-            <a:endParaRPr b="1" lang="en-IN" sz="2800" strike="noStrike" u="none">
-              <a:solidFill>
-                <a:srgbClr val="2c3e50"/>
-              </a:solidFill>
-              <a:effectLst/>
-              <a:uFillTx/>
-              <a:latin typeface="Noto Sans"/>
-            </a:endParaRPr>
-          </a:p>
-          <a:p>
-            <a:pPr marL="432000" indent="-324000">
-              <a:spcAft>
-                <a:spcPts val="1057"/>
-              </a:spcAft>
-              <a:buClr>
-                <a:srgbClr val="2c3e50"/>
-              </a:buClr>
-              <a:buSzPct val="45000"/>
-              <a:buFont typeface="OpenSymbol"/>
-              <a:buChar char="►"/>
-            </a:pPr>
-            <a:r>
-              <a:rPr b="1" lang="en-IN" sz="2800" strike="noStrike" u="none">
-                <a:solidFill>
-                  <a:srgbClr val="2c3e50"/>
-                </a:solidFill>
-                <a:effectLst/>
-                <a:uFillTx/>
-                <a:latin typeface="Noto Sans"/>
-              </a:rPr>
-              <a:t>head(), info(), describe()</a:t>
-            </a:r>
-            <a:endParaRPr b="1" lang="en-IN" sz="2800" strike="noStrike" u="none">
-              <a:solidFill>
-                <a:srgbClr val="2c3e50"/>
-              </a:solidFill>
-              <a:effectLst/>
-              <a:uFillTx/>
-              <a:latin typeface="Noto Sans"/>
-            </a:endParaRPr>
-          </a:p>
-          <a:p>
-            <a:pPr marL="432000" indent="-324000">
-              <a:spcAft>
-                <a:spcPts val="1057"/>
-              </a:spcAft>
-              <a:buClr>
-                <a:srgbClr val="2c3e50"/>
-              </a:buClr>
-              <a:buSzPct val="45000"/>
-              <a:buFont typeface="OpenSymbol"/>
-              <a:buChar char="►"/>
-            </a:pPr>
-            <a:r>
-              <a:rPr b="1" lang="en-IN" sz="2800" strike="noStrike" u="none">
-                <a:solidFill>
-                  <a:srgbClr val="2c3e50"/>
-                </a:solidFill>
-                <a:effectLst/>
-                <a:uFillTx/>
-                <a:latin typeface="Noto Sans"/>
-              </a:rPr>
-              <a:t>Filtering</a:t>
-            </a:r>
-            <a:endParaRPr b="1" lang="en-IN" sz="2800" strike="noStrike" u="none">
-              <a:solidFill>
-                <a:srgbClr val="2c3e50"/>
-              </a:solidFill>
-              <a:effectLst/>
-              <a:uFillTx/>
-              <a:latin typeface="Noto Sans"/>
-            </a:endParaRPr>
-          </a:p>
-          <a:p>
-            <a:pPr marL="432000" indent="-324000">
-              <a:spcAft>
-                <a:spcPts val="1057"/>
-              </a:spcAft>
-              <a:buClr>
-                <a:srgbClr val="2c3e50"/>
-              </a:buClr>
-              <a:buSzPct val="45000"/>
-              <a:buFont typeface="OpenSymbol"/>
-              <a:buChar char="►"/>
-            </a:pPr>
-            <a:r>
-              <a:rPr b="1" lang="en-IN" sz="2800" strike="noStrike" u="none">
-                <a:solidFill>
-                  <a:srgbClr val="2c3e50"/>
-                </a:solidFill>
-                <a:effectLst/>
-                <a:uFillTx/>
-                <a:latin typeface="Noto Sans"/>
-              </a:rPr>
-              <a:t>Mean Calculation</a:t>
-            </a:r>
-            <a:endParaRPr b="1" lang="en-IN" sz="2800" strike="noStrike" u="none">
-              <a:solidFill>
-                <a:srgbClr val="2c3e50"/>
-              </a:solidFill>
-              <a:effectLst/>
-              <a:uFillTx/>
-              <a:latin typeface="Noto Sans"/>
-            </a:endParaRPr>
-          </a:p>
-          <a:p>
-            <a:pPr marL="432000" indent="-324000">
-              <a:spcAft>
-                <a:spcPts val="1057"/>
-              </a:spcAft>
-              <a:buClr>
-                <a:srgbClr val="2c3e50"/>
-              </a:buClr>
-              <a:buSzPct val="45000"/>
-              <a:buFont typeface="OpenSymbol"/>
-              <a:buChar char="►"/>
-            </a:pPr>
-            <a:r>
-              <a:rPr b="1" lang="en-IN" sz="2800" strike="noStrike" u="none">
-                <a:solidFill>
-                  <a:srgbClr val="2c3e50"/>
-                </a:solidFill>
-                <a:effectLst/>
-                <a:uFillTx/>
-                <a:latin typeface="Noto Sans"/>
-              </a:rPr>
-              <a:t>Bar Chart, Histogram</a:t>
-            </a:r>
-            <a:endParaRPr b="1" lang="en-IN" sz="2800" strike="noStrike" u="none">
-              <a:solidFill>
-                <a:srgbClr val="2c3e50"/>
-              </a:solidFill>
-              <a:effectLst/>
-              <a:uFillTx/>
-              <a:latin typeface="Noto Sans"/>
-            </a:endParaRPr>
-          </a:p>
-        </p:txBody>
-      </p:sp>
-      <p:sp>
-        <p:nvSpPr>
-          <p:cNvPr id="33" name=""/>
-          <p:cNvSpPr/>
-          <p:nvPr/>
-        </p:nvSpPr>
-        <p:spPr>
-          <a:xfrm>
-            <a:off x="360000" y="4860360"/>
-            <a:ext cx="3600000" cy="540000"/>
-          </a:xfrm>
-          <a:prstGeom prst="flowChartAlternateProcess">
-            <a:avLst/>
-          </a:prstGeom>
-          <a:solidFill>
-            <a:srgbClr val="ff0000"/>
-          </a:solidFill>
-          <a:ln w="10800">
-            <a:solidFill>
-              <a:srgbClr val="1abc9c"/>
-            </a:solidFill>
-            <a:round/>
-          </a:ln>
-        </p:spPr>
-        <p:style>
-          <a:lnRef idx="0"/>
-          <a:fillRef idx="0"/>
-          <a:effectRef idx="0"/>
-          <a:fontRef idx="minor"/>
-        </p:style>
-        <p:txBody>
-          <a:bodyPr wrap="none" lIns="90000" rIns="90000" tIns="45000" bIns="45000" anchor="ctr">
-            <a:noAutofit/>
-          </a:bodyPr>
-          <a:p>
-            <a:pPr algn="ctr">
-              <a:lnSpc>
-                <a:spcPct val="100000"/>
-              </a:lnSpc>
-            </a:pPr>
-            <a:r>
-              <a:rPr b="1" lang="en-IN" sz="1800" strike="noStrike" u="none">
-                <a:solidFill>
-                  <a:srgbClr val="ffffff"/>
-                </a:solidFill>
-                <a:effectLst/>
-                <a:uFillTx/>
-                <a:latin typeface="Noto Sans"/>
-              </a:rPr>
-              <a:t>youtube.com/@ssutradhar35</a:t>
-            </a:r>
-            <a:endParaRPr b="0" lang="en-IN" sz="1800" strike="noStrike" u="none">
-              <a:solidFill>
-                <a:srgbClr val="2c3e50"/>
-              </a:solidFill>
-              <a:effectLst/>
-              <a:uFillTx/>
-              <a:latin typeface="Noto Sans"/>
-            </a:endParaRPr>
-          </a:p>
-        </p:txBody>
-      </p:sp>
-      <p:sp>
-        <p:nvSpPr>
-          <p:cNvPr id="4" name="PlaceHolder 3"/>
-          <p:cNvSpPr>
-            <a:spLocks noGrp="1"/>
-          </p:cNvSpPr>
-          <p:nvPr>
-            <p:ph type="sldNum" idx="3"/>
-          </p:nvPr>
-        </p:nvSpPr>
-        <p:spPr/>
-        <p:txBody>
-          <a:bodyPr/>
-          <a:p>
-            <a:fld id="{674343A8-D316-43DC-BFBC-DE7DFD75B05D}" type="slidenum">
-              <a:t>4</a:t>
             </a:fld>
           </a:p>
         </p:txBody>

</xml_diff>